<commit_message>
Pitch script — 4 versions (1/3/5/10 min) + Q&A + demo + tips
</commit_message>
<xml_diff>
--- a/docs/AuksionWatch_pitch.pptx
+++ b/docs/AuksionWatch_pitch.pptx
@@ -5,20 +5,20 @@
     <p:sldMasterId id="2147483648" r:id="rId1"/>
   </p:sldMasterIdLst>
   <p:sldIdLst>
-    <p:sldId id="256" r:id="rId7"/>
-    <p:sldId id="257" r:id="rId8"/>
-    <p:sldId id="258" r:id="rId9"/>
-    <p:sldId id="259" r:id="rId10"/>
-    <p:sldId id="260" r:id="rId11"/>
-    <p:sldId id="261" r:id="rId12"/>
-    <p:sldId id="262" r:id="rId13"/>
-    <p:sldId id="263" r:id="rId14"/>
-    <p:sldId id="264" r:id="rId15"/>
-    <p:sldId id="265" r:id="rId16"/>
-    <p:sldId id="266" r:id="rId17"/>
-    <p:sldId id="267" r:id="rId18"/>
+    <p:sldId id="256" r:id="rId2"/>
+    <p:sldId id="257" r:id="rId3"/>
+    <p:sldId id="258" r:id="rId4"/>
+    <p:sldId id="259" r:id="rId5"/>
+    <p:sldId id="260" r:id="rId6"/>
+    <p:sldId id="261" r:id="rId7"/>
+    <p:sldId id="262" r:id="rId8"/>
+    <p:sldId id="263" r:id="rId9"/>
+    <p:sldId id="264" r:id="rId10"/>
+    <p:sldId id="265" r:id="rId11"/>
+    <p:sldId id="266" r:id="rId12"/>
+    <p:sldId id="267" r:id="rId13"/>
   </p:sldIdLst>
-  <p:sldSz cx="12191695" cy="6858000" type="screen4x3"/>
+  <p:sldSz cx="12192000" cy="6858000"/>
   <p:notesSz cx="6858000" cy="9144000"/>
   <p:defaultTextStyle>
     <a:defPPr>
@@ -115,6 +115,22 @@
       </a:defRPr>
     </a:lvl9pPr>
   </p:defaultTextStyle>
+  <p:extLst>
+    <p:ext uri="{EFAFB233-063F-42B5-8137-9DF3F51BA10A}">
+      <p15:sldGuideLst xmlns:p15="http://schemas.microsoft.com/office/powerpoint/2012/main">
+        <p15:guide id="1" orient="horz" pos="2160">
+          <p15:clr>
+            <a:srgbClr val="A4A3A4"/>
+          </p15:clr>
+        </p15:guide>
+        <p15:guide id="2" pos="2880">
+          <p15:clr>
+            <a:srgbClr val="A4A3A4"/>
+          </p15:clr>
+        </p15:guide>
+      </p15:sldGuideLst>
+    </p:ext>
+  </p:extLst>
 </p:presentation>
 </file>
 
@@ -156,10 +172,9 @@
           <a:lstStyle/>
           <a:p>
             <a:r>
-              <a:rPr lang="en-US" smtClean="0"/>
+              <a:rPr lang="en-US"/>
               <a:t>Click to edit Master title style</a:t>
             </a:r>
-            <a:endParaRPr lang="en-US"/>
           </a:p>
         </p:txBody>
       </p:sp>
@@ -275,10 +290,9 @@
           </a:lstStyle>
           <a:p>
             <a:r>
-              <a:rPr lang="en-US" smtClean="0"/>
+              <a:rPr lang="en-US"/>
               <a:t>Click to edit Master subtitle style</a:t>
             </a:r>
-            <a:endParaRPr lang="en-US"/>
           </a:p>
         </p:txBody>
       </p:sp>
@@ -299,7 +313,7 @@
           <a:p>
             <a:fld id="{5BCAD085-E8A6-8845-BD4E-CB4CCA059FC4}" type="datetimeFigureOut">
               <a:rPr lang="en-US" smtClean="0"/>
-              <a:t>1/27/13</a:t>
+              <a:t>4/25/2026</a:t>
             </a:fld>
             <a:endParaRPr lang="en-US"/>
           </a:p>
@@ -393,10 +407,9 @@
           <a:lstStyle/>
           <a:p>
             <a:r>
-              <a:rPr lang="en-US" smtClean="0"/>
+              <a:rPr lang="en-US"/>
               <a:t>Click to edit Master title style</a:t>
             </a:r>
-            <a:endParaRPr lang="en-US"/>
           </a:p>
         </p:txBody>
       </p:sp>
@@ -417,38 +430,37 @@
           <a:p>
             <a:pPr lvl="0"/>
             <a:r>
-              <a:rPr lang="en-US" smtClean="0"/>
+              <a:rPr lang="en-US"/>
               <a:t>Click to edit Master text styles</a:t>
             </a:r>
           </a:p>
           <a:p>
             <a:pPr lvl="1"/>
             <a:r>
-              <a:rPr lang="en-US" smtClean="0"/>
+              <a:rPr lang="en-US"/>
               <a:t>Second level</a:t>
             </a:r>
           </a:p>
           <a:p>
             <a:pPr lvl="2"/>
             <a:r>
-              <a:rPr lang="en-US" smtClean="0"/>
+              <a:rPr lang="en-US"/>
               <a:t>Third level</a:t>
             </a:r>
           </a:p>
           <a:p>
             <a:pPr lvl="3"/>
             <a:r>
-              <a:rPr lang="en-US" smtClean="0"/>
+              <a:rPr lang="en-US"/>
               <a:t>Fourth level</a:t>
             </a:r>
           </a:p>
           <a:p>
             <a:pPr lvl="4"/>
             <a:r>
-              <a:rPr lang="en-US" smtClean="0"/>
+              <a:rPr lang="en-US"/>
               <a:t>Fifth level</a:t>
             </a:r>
-            <a:endParaRPr lang="en-US"/>
           </a:p>
         </p:txBody>
       </p:sp>
@@ -469,7 +481,7 @@
           <a:p>
             <a:fld id="{5BCAD085-E8A6-8845-BD4E-CB4CCA059FC4}" type="datetimeFigureOut">
               <a:rPr lang="en-US" smtClean="0"/>
-              <a:t>1/27/13</a:t>
+              <a:t>4/25/2026</a:t>
             </a:fld>
             <a:endParaRPr lang="en-US"/>
           </a:p>
@@ -568,10 +580,9 @@
           <a:lstStyle/>
           <a:p>
             <a:r>
-              <a:rPr lang="en-US" smtClean="0"/>
+              <a:rPr lang="en-US"/>
               <a:t>Click to edit Master title style</a:t>
             </a:r>
-            <a:endParaRPr lang="en-US"/>
           </a:p>
         </p:txBody>
       </p:sp>
@@ -597,38 +608,37 @@
           <a:p>
             <a:pPr lvl="0"/>
             <a:r>
-              <a:rPr lang="en-US" smtClean="0"/>
+              <a:rPr lang="en-US"/>
               <a:t>Click to edit Master text styles</a:t>
             </a:r>
           </a:p>
           <a:p>
             <a:pPr lvl="1"/>
             <a:r>
-              <a:rPr lang="en-US" smtClean="0"/>
+              <a:rPr lang="en-US"/>
               <a:t>Second level</a:t>
             </a:r>
           </a:p>
           <a:p>
             <a:pPr lvl="2"/>
             <a:r>
-              <a:rPr lang="en-US" smtClean="0"/>
+              <a:rPr lang="en-US"/>
               <a:t>Third level</a:t>
             </a:r>
           </a:p>
           <a:p>
             <a:pPr lvl="3"/>
             <a:r>
-              <a:rPr lang="en-US" smtClean="0"/>
+              <a:rPr lang="en-US"/>
               <a:t>Fourth level</a:t>
             </a:r>
           </a:p>
           <a:p>
             <a:pPr lvl="4"/>
             <a:r>
-              <a:rPr lang="en-US" smtClean="0"/>
+              <a:rPr lang="en-US"/>
               <a:t>Fifth level</a:t>
             </a:r>
-            <a:endParaRPr lang="en-US"/>
           </a:p>
         </p:txBody>
       </p:sp>
@@ -649,7 +659,7 @@
           <a:p>
             <a:fld id="{5BCAD085-E8A6-8845-BD4E-CB4CCA059FC4}" type="datetimeFigureOut">
               <a:rPr lang="en-US" smtClean="0"/>
-              <a:t>1/27/13</a:t>
+              <a:t>4/25/2026</a:t>
             </a:fld>
             <a:endParaRPr lang="en-US"/>
           </a:p>
@@ -743,10 +753,9 @@
           <a:lstStyle/>
           <a:p>
             <a:r>
-              <a:rPr lang="en-US" smtClean="0"/>
+              <a:rPr lang="en-US"/>
               <a:t>Click to edit Master title style</a:t>
             </a:r>
-            <a:endParaRPr lang="en-US"/>
           </a:p>
         </p:txBody>
       </p:sp>
@@ -767,38 +776,37 @@
           <a:p>
             <a:pPr lvl="0"/>
             <a:r>
-              <a:rPr lang="en-US" smtClean="0"/>
+              <a:rPr lang="en-US"/>
               <a:t>Click to edit Master text styles</a:t>
             </a:r>
           </a:p>
           <a:p>
             <a:pPr lvl="1"/>
             <a:r>
-              <a:rPr lang="en-US" smtClean="0"/>
+              <a:rPr lang="en-US"/>
               <a:t>Second level</a:t>
             </a:r>
           </a:p>
           <a:p>
             <a:pPr lvl="2"/>
             <a:r>
-              <a:rPr lang="en-US" smtClean="0"/>
+              <a:rPr lang="en-US"/>
               <a:t>Third level</a:t>
             </a:r>
           </a:p>
           <a:p>
             <a:pPr lvl="3"/>
             <a:r>
-              <a:rPr lang="en-US" smtClean="0"/>
+              <a:rPr lang="en-US"/>
               <a:t>Fourth level</a:t>
             </a:r>
           </a:p>
           <a:p>
             <a:pPr lvl="4"/>
             <a:r>
-              <a:rPr lang="en-US" smtClean="0"/>
+              <a:rPr lang="en-US"/>
               <a:t>Fifth level</a:t>
             </a:r>
-            <a:endParaRPr lang="en-US"/>
           </a:p>
         </p:txBody>
       </p:sp>
@@ -819,7 +827,7 @@
           <a:p>
             <a:fld id="{5BCAD085-E8A6-8845-BD4E-CB4CCA059FC4}" type="datetimeFigureOut">
               <a:rPr lang="en-US" smtClean="0"/>
-              <a:t>1/27/13</a:t>
+              <a:t>4/25/2026</a:t>
             </a:fld>
             <a:endParaRPr lang="en-US"/>
           </a:p>
@@ -922,10 +930,9 @@
           </a:lstStyle>
           <a:p>
             <a:r>
-              <a:rPr lang="en-US" smtClean="0"/>
+              <a:rPr lang="en-US"/>
               <a:t>Click to edit Master title style</a:t>
             </a:r>
-            <a:endParaRPr lang="en-US"/>
           </a:p>
         </p:txBody>
       </p:sp>
@@ -1042,7 +1049,7 @@
           <a:p>
             <a:pPr lvl="0"/>
             <a:r>
-              <a:rPr lang="en-US" smtClean="0"/>
+              <a:rPr lang="en-US"/>
               <a:t>Click to edit Master text styles</a:t>
             </a:r>
           </a:p>
@@ -1065,7 +1072,7 @@
           <a:p>
             <a:fld id="{5BCAD085-E8A6-8845-BD4E-CB4CCA059FC4}" type="datetimeFigureOut">
               <a:rPr lang="en-US" smtClean="0"/>
-              <a:t>1/27/13</a:t>
+              <a:t>4/25/2026</a:t>
             </a:fld>
             <a:endParaRPr lang="en-US"/>
           </a:p>
@@ -1159,10 +1166,9 @@
           <a:lstStyle/>
           <a:p>
             <a:r>
-              <a:rPr lang="en-US" smtClean="0"/>
+              <a:rPr lang="en-US"/>
               <a:t>Click to edit Master title style</a:t>
             </a:r>
-            <a:endParaRPr lang="en-US"/>
           </a:p>
         </p:txBody>
       </p:sp>
@@ -1216,38 +1222,37 @@
           <a:p>
             <a:pPr lvl="0"/>
             <a:r>
-              <a:rPr lang="en-US" smtClean="0"/>
+              <a:rPr lang="en-US"/>
               <a:t>Click to edit Master text styles</a:t>
             </a:r>
           </a:p>
           <a:p>
             <a:pPr lvl="1"/>
             <a:r>
-              <a:rPr lang="en-US" smtClean="0"/>
+              <a:rPr lang="en-US"/>
               <a:t>Second level</a:t>
             </a:r>
           </a:p>
           <a:p>
             <a:pPr lvl="2"/>
             <a:r>
-              <a:rPr lang="en-US" smtClean="0"/>
+              <a:rPr lang="en-US"/>
               <a:t>Third level</a:t>
             </a:r>
           </a:p>
           <a:p>
             <a:pPr lvl="3"/>
             <a:r>
-              <a:rPr lang="en-US" smtClean="0"/>
+              <a:rPr lang="en-US"/>
               <a:t>Fourth level</a:t>
             </a:r>
           </a:p>
           <a:p>
             <a:pPr lvl="4"/>
             <a:r>
-              <a:rPr lang="en-US" smtClean="0"/>
+              <a:rPr lang="en-US"/>
               <a:t>Fifth level</a:t>
             </a:r>
-            <a:endParaRPr lang="en-US"/>
           </a:p>
         </p:txBody>
       </p:sp>
@@ -1301,38 +1306,37 @@
           <a:p>
             <a:pPr lvl="0"/>
             <a:r>
-              <a:rPr lang="en-US" smtClean="0"/>
+              <a:rPr lang="en-US"/>
               <a:t>Click to edit Master text styles</a:t>
             </a:r>
           </a:p>
           <a:p>
             <a:pPr lvl="1"/>
             <a:r>
-              <a:rPr lang="en-US" smtClean="0"/>
+              <a:rPr lang="en-US"/>
               <a:t>Second level</a:t>
             </a:r>
           </a:p>
           <a:p>
             <a:pPr lvl="2"/>
             <a:r>
-              <a:rPr lang="en-US" smtClean="0"/>
+              <a:rPr lang="en-US"/>
               <a:t>Third level</a:t>
             </a:r>
           </a:p>
           <a:p>
             <a:pPr lvl="3"/>
             <a:r>
-              <a:rPr lang="en-US" smtClean="0"/>
+              <a:rPr lang="en-US"/>
               <a:t>Fourth level</a:t>
             </a:r>
           </a:p>
           <a:p>
             <a:pPr lvl="4"/>
             <a:r>
-              <a:rPr lang="en-US" smtClean="0"/>
+              <a:rPr lang="en-US"/>
               <a:t>Fifth level</a:t>
             </a:r>
-            <a:endParaRPr lang="en-US"/>
           </a:p>
         </p:txBody>
       </p:sp>
@@ -1353,7 +1357,7 @@
           <a:p>
             <a:fld id="{5BCAD085-E8A6-8845-BD4E-CB4CCA059FC4}" type="datetimeFigureOut">
               <a:rPr lang="en-US" smtClean="0"/>
-              <a:t>1/27/13</a:t>
+              <a:t>4/25/2026</a:t>
             </a:fld>
             <a:endParaRPr lang="en-US"/>
           </a:p>
@@ -1451,10 +1455,9 @@
           </a:lstStyle>
           <a:p>
             <a:r>
-              <a:rPr lang="en-US" smtClean="0"/>
+              <a:rPr lang="en-US"/>
               <a:t>Click to edit Master title style</a:t>
             </a:r>
-            <a:endParaRPr lang="en-US"/>
           </a:p>
         </p:txBody>
       </p:sp>
@@ -1517,7 +1520,7 @@
           <a:p>
             <a:pPr lvl="0"/>
             <a:r>
-              <a:rPr lang="en-US" smtClean="0"/>
+              <a:rPr lang="en-US"/>
               <a:t>Click to edit Master text styles</a:t>
             </a:r>
           </a:p>
@@ -1573,38 +1576,37 @@
           <a:p>
             <a:pPr lvl="0"/>
             <a:r>
-              <a:rPr lang="en-US" smtClean="0"/>
+              <a:rPr lang="en-US"/>
               <a:t>Click to edit Master text styles</a:t>
             </a:r>
           </a:p>
           <a:p>
             <a:pPr lvl="1"/>
             <a:r>
-              <a:rPr lang="en-US" smtClean="0"/>
+              <a:rPr lang="en-US"/>
               <a:t>Second level</a:t>
             </a:r>
           </a:p>
           <a:p>
             <a:pPr lvl="2"/>
             <a:r>
-              <a:rPr lang="en-US" smtClean="0"/>
+              <a:rPr lang="en-US"/>
               <a:t>Third level</a:t>
             </a:r>
           </a:p>
           <a:p>
             <a:pPr lvl="3"/>
             <a:r>
-              <a:rPr lang="en-US" smtClean="0"/>
+              <a:rPr lang="en-US"/>
               <a:t>Fourth level</a:t>
             </a:r>
           </a:p>
           <a:p>
             <a:pPr lvl="4"/>
             <a:r>
-              <a:rPr lang="en-US" smtClean="0"/>
+              <a:rPr lang="en-US"/>
               <a:t>Fifth level</a:t>
             </a:r>
-            <a:endParaRPr lang="en-US"/>
           </a:p>
         </p:txBody>
       </p:sp>
@@ -1667,7 +1669,7 @@
           <a:p>
             <a:pPr lvl="0"/>
             <a:r>
-              <a:rPr lang="en-US" smtClean="0"/>
+              <a:rPr lang="en-US"/>
               <a:t>Click to edit Master text styles</a:t>
             </a:r>
           </a:p>
@@ -1723,38 +1725,37 @@
           <a:p>
             <a:pPr lvl="0"/>
             <a:r>
-              <a:rPr lang="en-US" smtClean="0"/>
+              <a:rPr lang="en-US"/>
               <a:t>Click to edit Master text styles</a:t>
             </a:r>
           </a:p>
           <a:p>
             <a:pPr lvl="1"/>
             <a:r>
-              <a:rPr lang="en-US" smtClean="0"/>
+              <a:rPr lang="en-US"/>
               <a:t>Second level</a:t>
             </a:r>
           </a:p>
           <a:p>
             <a:pPr lvl="2"/>
             <a:r>
-              <a:rPr lang="en-US" smtClean="0"/>
+              <a:rPr lang="en-US"/>
               <a:t>Third level</a:t>
             </a:r>
           </a:p>
           <a:p>
             <a:pPr lvl="3"/>
             <a:r>
-              <a:rPr lang="en-US" smtClean="0"/>
+              <a:rPr lang="en-US"/>
               <a:t>Fourth level</a:t>
             </a:r>
           </a:p>
           <a:p>
             <a:pPr lvl="4"/>
             <a:r>
-              <a:rPr lang="en-US" smtClean="0"/>
+              <a:rPr lang="en-US"/>
               <a:t>Fifth level</a:t>
             </a:r>
-            <a:endParaRPr lang="en-US"/>
           </a:p>
         </p:txBody>
       </p:sp>
@@ -1775,7 +1776,7 @@
           <a:p>
             <a:fld id="{5BCAD085-E8A6-8845-BD4E-CB4CCA059FC4}" type="datetimeFigureOut">
               <a:rPr lang="en-US" smtClean="0"/>
-              <a:t>1/27/13</a:t>
+              <a:t>4/25/2026</a:t>
             </a:fld>
             <a:endParaRPr lang="en-US"/>
           </a:p>
@@ -1869,10 +1870,9 @@
           <a:lstStyle/>
           <a:p>
             <a:r>
-              <a:rPr lang="en-US" smtClean="0"/>
+              <a:rPr lang="en-US"/>
               <a:t>Click to edit Master title style</a:t>
             </a:r>
-            <a:endParaRPr lang="en-US"/>
           </a:p>
         </p:txBody>
       </p:sp>
@@ -1893,7 +1893,7 @@
           <a:p>
             <a:fld id="{5BCAD085-E8A6-8845-BD4E-CB4CCA059FC4}" type="datetimeFigureOut">
               <a:rPr lang="en-US" smtClean="0"/>
-              <a:t>1/27/13</a:t>
+              <a:t>4/25/2026</a:t>
             </a:fld>
             <a:endParaRPr lang="en-US"/>
           </a:p>
@@ -1988,7 +1988,7 @@
           <a:p>
             <a:fld id="{5BCAD085-E8A6-8845-BD4E-CB4CCA059FC4}" type="datetimeFigureOut">
               <a:rPr lang="en-US" smtClean="0"/>
-              <a:t>1/27/13</a:t>
+              <a:t>4/25/2026</a:t>
             </a:fld>
             <a:endParaRPr lang="en-US"/>
           </a:p>
@@ -2091,10 +2091,9 @@
           </a:lstStyle>
           <a:p>
             <a:r>
-              <a:rPr lang="en-US" smtClean="0"/>
+              <a:rPr lang="en-US"/>
               <a:t>Click to edit Master title style</a:t>
             </a:r>
-            <a:endParaRPr lang="en-US"/>
           </a:p>
         </p:txBody>
       </p:sp>
@@ -2148,38 +2147,37 @@
           <a:p>
             <a:pPr lvl="0"/>
             <a:r>
-              <a:rPr lang="en-US" smtClean="0"/>
+              <a:rPr lang="en-US"/>
               <a:t>Click to edit Master text styles</a:t>
             </a:r>
           </a:p>
           <a:p>
             <a:pPr lvl="1"/>
             <a:r>
-              <a:rPr lang="en-US" smtClean="0"/>
+              <a:rPr lang="en-US"/>
               <a:t>Second level</a:t>
             </a:r>
           </a:p>
           <a:p>
             <a:pPr lvl="2"/>
             <a:r>
-              <a:rPr lang="en-US" smtClean="0"/>
+              <a:rPr lang="en-US"/>
               <a:t>Third level</a:t>
             </a:r>
           </a:p>
           <a:p>
             <a:pPr lvl="3"/>
             <a:r>
-              <a:rPr lang="en-US" smtClean="0"/>
+              <a:rPr lang="en-US"/>
               <a:t>Fourth level</a:t>
             </a:r>
           </a:p>
           <a:p>
             <a:pPr lvl="4"/>
             <a:r>
-              <a:rPr lang="en-US" smtClean="0"/>
+              <a:rPr lang="en-US"/>
               <a:t>Fifth level</a:t>
             </a:r>
-            <a:endParaRPr lang="en-US"/>
           </a:p>
         </p:txBody>
       </p:sp>
@@ -2242,7 +2240,7 @@
           <a:p>
             <a:pPr lvl="0"/>
             <a:r>
-              <a:rPr lang="en-US" smtClean="0"/>
+              <a:rPr lang="en-US"/>
               <a:t>Click to edit Master text styles</a:t>
             </a:r>
           </a:p>
@@ -2265,7 +2263,7 @@
           <a:p>
             <a:fld id="{5BCAD085-E8A6-8845-BD4E-CB4CCA059FC4}" type="datetimeFigureOut">
               <a:rPr lang="en-US" smtClean="0"/>
-              <a:t>1/27/13</a:t>
+              <a:t>4/25/2026</a:t>
             </a:fld>
             <a:endParaRPr lang="en-US"/>
           </a:p>
@@ -2368,10 +2366,9 @@
           </a:lstStyle>
           <a:p>
             <a:r>
-              <a:rPr lang="en-US" smtClean="0"/>
+              <a:rPr lang="en-US"/>
               <a:t>Click to edit Master title style</a:t>
             </a:r>
-            <a:endParaRPr lang="en-US"/>
           </a:p>
         </p:txBody>
       </p:sp>
@@ -2495,7 +2492,7 @@
           <a:p>
             <a:pPr lvl="0"/>
             <a:r>
-              <a:rPr lang="en-US" smtClean="0"/>
+              <a:rPr lang="en-US"/>
               <a:t>Click to edit Master text styles</a:t>
             </a:r>
           </a:p>
@@ -2518,7 +2515,7 @@
           <a:p>
             <a:fld id="{5BCAD085-E8A6-8845-BD4E-CB4CCA059FC4}" type="datetimeFigureOut">
               <a:rPr lang="en-US" smtClean="0"/>
-              <a:t>1/27/13</a:t>
+              <a:t>4/25/2026</a:t>
             </a:fld>
             <a:endParaRPr lang="en-US"/>
           </a:p>
@@ -2627,10 +2624,9 @@
           <a:lstStyle/>
           <a:p>
             <a:r>
-              <a:rPr lang="en-US" smtClean="0"/>
+              <a:rPr lang="en-US"/>
               <a:t>Click to edit Master title style</a:t>
             </a:r>
-            <a:endParaRPr lang="en-US"/>
           </a:p>
         </p:txBody>
       </p:sp>
@@ -2661,38 +2657,37 @@
           <a:p>
             <a:pPr lvl="0"/>
             <a:r>
-              <a:rPr lang="en-US" smtClean="0"/>
+              <a:rPr lang="en-US"/>
               <a:t>Click to edit Master text styles</a:t>
             </a:r>
           </a:p>
           <a:p>
             <a:pPr lvl="1"/>
             <a:r>
-              <a:rPr lang="en-US" smtClean="0"/>
+              <a:rPr lang="en-US"/>
               <a:t>Second level</a:t>
             </a:r>
           </a:p>
           <a:p>
             <a:pPr lvl="2"/>
             <a:r>
-              <a:rPr lang="en-US" smtClean="0"/>
+              <a:rPr lang="en-US"/>
               <a:t>Third level</a:t>
             </a:r>
           </a:p>
           <a:p>
             <a:pPr lvl="3"/>
             <a:r>
-              <a:rPr lang="en-US" smtClean="0"/>
+              <a:rPr lang="en-US"/>
               <a:t>Fourth level</a:t>
             </a:r>
           </a:p>
           <a:p>
             <a:pPr lvl="4"/>
             <a:r>
-              <a:rPr lang="en-US" smtClean="0"/>
+              <a:rPr lang="en-US"/>
               <a:t>Fifth level</a:t>
             </a:r>
-            <a:endParaRPr lang="en-US"/>
           </a:p>
         </p:txBody>
       </p:sp>
@@ -2731,7 +2726,7 @@
           <a:p>
             <a:fld id="{5BCAD085-E8A6-8845-BD4E-CB4CCA059FC4}" type="datetimeFigureOut">
               <a:rPr lang="en-US" smtClean="0"/>
-              <a:t>1/27/13</a:t>
+              <a:t>4/25/2026</a:t>
             </a:fld>
             <a:endParaRPr lang="en-US"/>
           </a:p>
@@ -3090,7 +3085,7 @@
 </file>
 
 <file path=ppt/slides/slide1.xml><?xml version="1.0" encoding="utf-8"?>
-<p:sld xmlns:a="http://schemas.openxmlformats.org/drawingml/2006/main" xmlns:p="http://schemas.openxmlformats.org/presentationml/2006/main" xmlns:r="http://schemas.openxmlformats.org/officeDocument/2006/relationships">
+<p:sld xmlns:a="http://schemas.openxmlformats.org/drawingml/2006/main" xmlns:r="http://schemas.openxmlformats.org/officeDocument/2006/relationships" xmlns:p="http://schemas.openxmlformats.org/presentationml/2006/main">
   <p:cSld>
     <p:spTree>
       <p:nvGrpSpPr>
@@ -3098,7 +3093,14 @@
         <p:cNvGrpSpPr/>
         <p:nvPr/>
       </p:nvGrpSpPr>
-      <p:grpSpPr/>
+      <p:grpSpPr>
+        <a:xfrm>
+          <a:off x="0" y="0"/>
+          <a:ext cx="0" cy="0"/>
+          <a:chOff x="0" y="0"/>
+          <a:chExt cx="0" cy="0"/>
+        </a:xfrm>
+      </p:grpSpPr>
       <p:sp>
         <p:nvSpPr>
           <p:cNvPr id="2" name="Rectangle 1"/>
@@ -3139,6 +3141,7 @@
           <a:lstStyle/>
           <a:p>
             <a:pPr algn="ctr"/>
+            <a:endParaRPr/>
           </a:p>
         </p:txBody>
       </p:sp>
@@ -3182,6 +3185,7 @@
           <a:lstStyle/>
           <a:p>
             <a:pPr algn="ctr"/>
+            <a:endParaRPr/>
           </a:p>
         </p:txBody>
       </p:sp>
@@ -3225,6 +3229,7 @@
           <a:lstStyle/>
           <a:p>
             <a:pPr algn="ctr"/>
+            <a:endParaRPr/>
           </a:p>
         </p:txBody>
       </p:sp>
@@ -3264,7 +3269,7 @@
           </a:fontRef>
         </p:style>
         <p:txBody>
-          <a:bodyPr rtlCol="0" anchor="ctr" lIns="0" rIns="0" tIns="0" bIns="0"/>
+          <a:bodyPr lIns="0" tIns="0" rIns="0" bIns="0" rtlCol="0" anchor="ctr"/>
           <a:lstStyle/>
           <a:p>
             <a:pPr algn="ctr"/>
@@ -3297,7 +3302,7 @@
           <a:noFill/>
         </p:spPr>
         <p:txBody>
-          <a:bodyPr wrap="square" anchor="t" lIns="0" rIns="0" tIns="0" bIns="0">
+          <a:bodyPr wrap="square" lIns="0" tIns="0" rIns="0" bIns="0" anchor="t">
             <a:spAutoFit/>
           </a:bodyPr>
           <a:lstStyle/>
@@ -3332,14 +3337,14 @@
           <a:noFill/>
         </p:spPr>
         <p:txBody>
-          <a:bodyPr wrap="square" anchor="t" lIns="0" rIns="0" tIns="0" bIns="0">
-            <a:spAutoFit/>
-          </a:bodyPr>
-          <a:lstStyle/>
-          <a:p>
-            <a:pPr algn="l"/>
-            <a:r>
-              <a:rPr sz="5800" b="1">
+          <a:bodyPr wrap="square" lIns="0" tIns="0" rIns="0" bIns="0" anchor="t">
+            <a:spAutoFit/>
+          </a:bodyPr>
+          <a:lstStyle/>
+          <a:p>
+            <a:pPr algn="l"/>
+            <a:r>
+              <a:rPr sz="5800" b="1" dirty="0" err="1">
                 <a:solidFill>
                   <a:srgbClr val="FFFFFF"/>
                 </a:solidFill>
@@ -3347,6 +3352,12 @@
               </a:rPr>
               <a:t>AuksionWatch</a:t>
             </a:r>
+            <a:endParaRPr sz="5800" b="1" dirty="0">
+              <a:solidFill>
+                <a:srgbClr val="FFFFFF"/>
+              </a:solidFill>
+              <a:latin typeface="Inter"/>
+            </a:endParaRPr>
           </a:p>
         </p:txBody>
       </p:sp>
@@ -3367,7 +3378,7 @@
           <a:noFill/>
         </p:spPr>
         <p:txBody>
-          <a:bodyPr wrap="square" anchor="t" lIns="0" rIns="0" tIns="0" bIns="0">
+          <a:bodyPr wrap="square" lIns="0" tIns="0" rIns="0" bIns="0" anchor="t">
             <a:spAutoFit/>
           </a:bodyPr>
           <a:lstStyle/>
@@ -3402,7 +3413,7 @@
           <a:noFill/>
         </p:spPr>
         <p:txBody>
-          <a:bodyPr wrap="square" anchor="t" lIns="0" rIns="0" tIns="0" bIns="0">
+          <a:bodyPr wrap="square" lIns="0" tIns="0" rIns="0" bIns="0" anchor="t">
             <a:spAutoFit/>
           </a:bodyPr>
           <a:lstStyle/>
@@ -3460,6 +3471,7 @@
           <a:lstStyle/>
           <a:p>
             <a:pPr algn="ctr"/>
+            <a:endParaRPr/>
           </a:p>
         </p:txBody>
       </p:sp>
@@ -3480,7 +3492,7 @@
           <a:noFill/>
         </p:spPr>
         <p:txBody>
-          <a:bodyPr wrap="square" anchor="t" lIns="0" rIns="0" tIns="0" bIns="0">
+          <a:bodyPr wrap="square" lIns="0" tIns="0" rIns="0" bIns="0" anchor="t">
             <a:spAutoFit/>
           </a:bodyPr>
           <a:lstStyle/>
@@ -3515,7 +3527,7 @@
           <a:noFill/>
         </p:spPr>
         <p:txBody>
-          <a:bodyPr wrap="square" anchor="t" lIns="0" rIns="0" tIns="0" bIns="0">
+          <a:bodyPr wrap="square" lIns="0" tIns="0" rIns="0" bIns="0" anchor="t">
             <a:spAutoFit/>
           </a:bodyPr>
           <a:lstStyle/>
@@ -3542,7 +3554,7 @@
 </file>
 
 <file path=ppt/slides/slide10.xml><?xml version="1.0" encoding="utf-8"?>
-<p:sld xmlns:a="http://schemas.openxmlformats.org/drawingml/2006/main" xmlns:p="http://schemas.openxmlformats.org/presentationml/2006/main" xmlns:r="http://schemas.openxmlformats.org/officeDocument/2006/relationships">
+<p:sld xmlns:a="http://schemas.openxmlformats.org/drawingml/2006/main" xmlns:r="http://schemas.openxmlformats.org/officeDocument/2006/relationships" xmlns:p="http://schemas.openxmlformats.org/presentationml/2006/main">
   <p:cSld>
     <p:spTree>
       <p:nvGrpSpPr>
@@ -3550,7 +3562,14 @@
         <p:cNvGrpSpPr/>
         <p:nvPr/>
       </p:nvGrpSpPr>
-      <p:grpSpPr/>
+      <p:grpSpPr>
+        <a:xfrm>
+          <a:off x="0" y="0"/>
+          <a:ext cx="0" cy="0"/>
+          <a:chOff x="0" y="0"/>
+          <a:chExt cx="0" cy="0"/>
+        </a:xfrm>
+      </p:grpSpPr>
       <p:sp>
         <p:nvSpPr>
           <p:cNvPr id="2" name="Rectangle 1"/>
@@ -3591,6 +3610,7 @@
           <a:lstStyle/>
           <a:p>
             <a:pPr algn="ctr"/>
+            <a:endParaRPr/>
           </a:p>
         </p:txBody>
       </p:sp>
@@ -3634,6 +3654,7 @@
           <a:lstStyle/>
           <a:p>
             <a:pPr algn="ctr"/>
+            <a:endParaRPr/>
           </a:p>
         </p:txBody>
       </p:sp>
@@ -3673,7 +3694,7 @@
           </a:fontRef>
         </p:style>
         <p:txBody>
-          <a:bodyPr rtlCol="0" anchor="ctr" lIns="0" rIns="0" tIns="0" bIns="0"/>
+          <a:bodyPr lIns="0" tIns="0" rIns="0" bIns="0" rtlCol="0" anchor="ctr"/>
           <a:lstStyle/>
           <a:p>
             <a:pPr algn="ctr"/>
@@ -3706,7 +3727,7 @@
           <a:noFill/>
         </p:spPr>
         <p:txBody>
-          <a:bodyPr wrap="square" anchor="t" lIns="0" rIns="0" tIns="0" bIns="0">
+          <a:bodyPr wrap="square" lIns="0" tIns="0" rIns="0" bIns="0" anchor="t">
             <a:spAutoFit/>
           </a:bodyPr>
           <a:lstStyle/>
@@ -3741,7 +3762,7 @@
           <a:noFill/>
         </p:spPr>
         <p:txBody>
-          <a:bodyPr wrap="square" anchor="t" lIns="0" rIns="0" tIns="0" bIns="0">
+          <a:bodyPr wrap="square" lIns="0" tIns="0" rIns="0" bIns="0" anchor="t">
             <a:spAutoFit/>
           </a:bodyPr>
           <a:lstStyle/>
@@ -3776,7 +3797,7 @@
           <a:noFill/>
         </p:spPr>
         <p:txBody>
-          <a:bodyPr wrap="square" anchor="t" lIns="0" rIns="0" tIns="0" bIns="0">
+          <a:bodyPr wrap="square" lIns="0" tIns="0" rIns="0" bIns="0" anchor="t">
             <a:spAutoFit/>
           </a:bodyPr>
           <a:lstStyle/>
@@ -3811,7 +3832,7 @@
           <a:noFill/>
         </p:spPr>
         <p:txBody>
-          <a:bodyPr wrap="square" anchor="t" lIns="0" rIns="0" tIns="0" bIns="0">
+          <a:bodyPr wrap="square" lIns="0" tIns="0" rIns="0" bIns="0" anchor="t">
             <a:spAutoFit/>
           </a:bodyPr>
           <a:lstStyle/>
@@ -3871,6 +3892,7 @@
           <a:lstStyle/>
           <a:p>
             <a:pPr algn="ctr"/>
+            <a:endParaRPr/>
           </a:p>
         </p:txBody>
       </p:sp>
@@ -3891,7 +3913,7 @@
           <a:noFill/>
         </p:spPr>
         <p:txBody>
-          <a:bodyPr wrap="square" anchor="t" lIns="0" rIns="0" tIns="0" bIns="0">
+          <a:bodyPr wrap="square" lIns="0" tIns="0" rIns="0" bIns="0" anchor="t">
             <a:spAutoFit/>
           </a:bodyPr>
           <a:lstStyle/>
@@ -3926,7 +3948,7 @@
           <a:noFill/>
         </p:spPr>
         <p:txBody>
-          <a:bodyPr wrap="square" anchor="t" lIns="0" rIns="0" tIns="0" bIns="0">
+          <a:bodyPr wrap="square" lIns="0" tIns="0" rIns="0" bIns="0" anchor="t">
             <a:spAutoFit/>
           </a:bodyPr>
           <a:lstStyle/>
@@ -3961,7 +3983,7 @@
           <a:noFill/>
         </p:spPr>
         <p:txBody>
-          <a:bodyPr wrap="square" anchor="t" lIns="0" rIns="0" tIns="0" bIns="0">
+          <a:bodyPr wrap="square" lIns="0" tIns="0" rIns="0" bIns="0" anchor="t">
             <a:spAutoFit/>
           </a:bodyPr>
           <a:lstStyle/>
@@ -4021,6 +4043,7 @@
           <a:lstStyle/>
           <a:p>
             <a:pPr algn="ctr"/>
+            <a:endParaRPr/>
           </a:p>
         </p:txBody>
       </p:sp>
@@ -4041,7 +4064,7 @@
           <a:noFill/>
         </p:spPr>
         <p:txBody>
-          <a:bodyPr wrap="square" anchor="t" lIns="0" rIns="0" tIns="0" bIns="0">
+          <a:bodyPr wrap="square" lIns="0" tIns="0" rIns="0" bIns="0" anchor="t">
             <a:spAutoFit/>
           </a:bodyPr>
           <a:lstStyle/>
@@ -4076,7 +4099,7 @@
           <a:noFill/>
         </p:spPr>
         <p:txBody>
-          <a:bodyPr wrap="square" anchor="t" lIns="0" rIns="0" tIns="0" bIns="0">
+          <a:bodyPr wrap="square" lIns="0" tIns="0" rIns="0" bIns="0" anchor="t">
             <a:spAutoFit/>
           </a:bodyPr>
           <a:lstStyle/>
@@ -4111,7 +4134,7 @@
           <a:noFill/>
         </p:spPr>
         <p:txBody>
-          <a:bodyPr wrap="square" anchor="t" lIns="0" rIns="0" tIns="0" bIns="0">
+          <a:bodyPr wrap="square" lIns="0" tIns="0" rIns="0" bIns="0" anchor="t">
             <a:spAutoFit/>
           </a:bodyPr>
           <a:lstStyle/>
@@ -4171,6 +4194,7 @@
           <a:lstStyle/>
           <a:p>
             <a:pPr algn="ctr"/>
+            <a:endParaRPr/>
           </a:p>
         </p:txBody>
       </p:sp>
@@ -4191,7 +4215,7 @@
           <a:noFill/>
         </p:spPr>
         <p:txBody>
-          <a:bodyPr wrap="square" anchor="t" lIns="0" rIns="0" tIns="0" bIns="0">
+          <a:bodyPr wrap="square" lIns="0" tIns="0" rIns="0" bIns="0" anchor="t">
             <a:spAutoFit/>
           </a:bodyPr>
           <a:lstStyle/>
@@ -4226,7 +4250,7 @@
           <a:noFill/>
         </p:spPr>
         <p:txBody>
-          <a:bodyPr wrap="square" anchor="t" lIns="0" rIns="0" tIns="0" bIns="0">
+          <a:bodyPr wrap="square" lIns="0" tIns="0" rIns="0" bIns="0" anchor="t">
             <a:spAutoFit/>
           </a:bodyPr>
           <a:lstStyle/>
@@ -4261,7 +4285,7 @@
           <a:noFill/>
         </p:spPr>
         <p:txBody>
-          <a:bodyPr wrap="square" anchor="t" lIns="0" rIns="0" tIns="0" bIns="0">
+          <a:bodyPr wrap="square" lIns="0" tIns="0" rIns="0" bIns="0" anchor="t">
             <a:spAutoFit/>
           </a:bodyPr>
           <a:lstStyle/>
@@ -4321,6 +4345,7 @@
           <a:lstStyle/>
           <a:p>
             <a:pPr algn="ctr"/>
+            <a:endParaRPr/>
           </a:p>
         </p:txBody>
       </p:sp>
@@ -4341,7 +4366,7 @@
           <a:noFill/>
         </p:spPr>
         <p:txBody>
-          <a:bodyPr wrap="square" anchor="t" lIns="0" rIns="0" tIns="0" bIns="0">
+          <a:bodyPr wrap="square" lIns="0" tIns="0" rIns="0" bIns="0" anchor="t">
             <a:spAutoFit/>
           </a:bodyPr>
           <a:lstStyle/>
@@ -4376,7 +4401,7 @@
           <a:noFill/>
         </p:spPr>
         <p:txBody>
-          <a:bodyPr wrap="square" anchor="t" lIns="0" rIns="0" tIns="0" bIns="0">
+          <a:bodyPr wrap="square" lIns="0" tIns="0" rIns="0" bIns="0" anchor="t">
             <a:spAutoFit/>
           </a:bodyPr>
           <a:lstStyle/>
@@ -4411,7 +4436,7 @@
           <a:noFill/>
         </p:spPr>
         <p:txBody>
-          <a:bodyPr wrap="square" anchor="t" lIns="0" rIns="0" tIns="0" bIns="0">
+          <a:bodyPr wrap="square" lIns="0" tIns="0" rIns="0" bIns="0" anchor="t">
             <a:spAutoFit/>
           </a:bodyPr>
           <a:lstStyle/>
@@ -4471,6 +4496,7 @@
           <a:lstStyle/>
           <a:p>
             <a:pPr algn="ctr"/>
+            <a:endParaRPr/>
           </a:p>
         </p:txBody>
       </p:sp>
@@ -4491,7 +4517,7 @@
           <a:noFill/>
         </p:spPr>
         <p:txBody>
-          <a:bodyPr wrap="square" anchor="t" lIns="0" rIns="0" tIns="0" bIns="0">
+          <a:bodyPr wrap="square" lIns="0" tIns="0" rIns="0" bIns="0" anchor="t">
             <a:spAutoFit/>
           </a:bodyPr>
           <a:lstStyle/>
@@ -4526,7 +4552,7 @@
           <a:noFill/>
         </p:spPr>
         <p:txBody>
-          <a:bodyPr wrap="square" anchor="t" lIns="0" rIns="0" tIns="0" bIns="0">
+          <a:bodyPr wrap="square" lIns="0" tIns="0" rIns="0" bIns="0" anchor="t">
             <a:spAutoFit/>
           </a:bodyPr>
           <a:lstStyle/>
@@ -4561,7 +4587,7 @@
           <a:noFill/>
         </p:spPr>
         <p:txBody>
-          <a:bodyPr wrap="square" anchor="t" lIns="0" rIns="0" tIns="0" bIns="0">
+          <a:bodyPr wrap="square" lIns="0" tIns="0" rIns="0" bIns="0" anchor="t">
             <a:spAutoFit/>
           </a:bodyPr>
           <a:lstStyle/>
@@ -4619,6 +4645,7 @@
           <a:lstStyle/>
           <a:p>
             <a:pPr algn="ctr"/>
+            <a:endParaRPr/>
           </a:p>
         </p:txBody>
       </p:sp>
@@ -4639,7 +4666,7 @@
           <a:noFill/>
         </p:spPr>
         <p:txBody>
-          <a:bodyPr wrap="square" anchor="t" lIns="0" rIns="0" tIns="0" bIns="0">
+          <a:bodyPr wrap="square" lIns="0" tIns="0" rIns="0" bIns="0" anchor="t">
             <a:spAutoFit/>
           </a:bodyPr>
           <a:lstStyle/>
@@ -4674,7 +4701,7 @@
           <a:noFill/>
         </p:spPr>
         <p:txBody>
-          <a:bodyPr wrap="square" anchor="t" lIns="0" rIns="0" tIns="0" bIns="0">
+          <a:bodyPr wrap="square" lIns="0" tIns="0" rIns="0" bIns="0" anchor="t">
             <a:spAutoFit/>
           </a:bodyPr>
           <a:lstStyle/>
@@ -4709,7 +4736,7 @@
           <a:noFill/>
         </p:spPr>
         <p:txBody>
-          <a:bodyPr wrap="square" anchor="t" lIns="0" rIns="0" tIns="0" bIns="0">
+          <a:bodyPr wrap="square" lIns="0" tIns="0" rIns="0" bIns="0" anchor="t">
             <a:spAutoFit/>
           </a:bodyPr>
           <a:lstStyle/>
@@ -4744,7 +4771,7 @@
           <a:noFill/>
         </p:spPr>
         <p:txBody>
-          <a:bodyPr wrap="square" anchor="t" lIns="0" rIns="0" tIns="0" bIns="0">
+          <a:bodyPr wrap="square" lIns="0" tIns="0" rIns="0" bIns="0" anchor="t">
             <a:spAutoFit/>
           </a:bodyPr>
           <a:lstStyle/>
@@ -4779,7 +4806,7 @@
           <a:noFill/>
         </p:spPr>
         <p:txBody>
-          <a:bodyPr wrap="square" anchor="t" lIns="0" rIns="0" tIns="0" bIns="0">
+          <a:bodyPr wrap="square" lIns="0" tIns="0" rIns="0" bIns="0" anchor="t">
             <a:spAutoFit/>
           </a:bodyPr>
           <a:lstStyle/>
@@ -4814,7 +4841,7 @@
           <a:noFill/>
         </p:spPr>
         <p:txBody>
-          <a:bodyPr wrap="square" anchor="t" lIns="0" rIns="0" tIns="0" bIns="0">
+          <a:bodyPr wrap="square" lIns="0" tIns="0" rIns="0" bIns="0" anchor="t">
             <a:spAutoFit/>
           </a:bodyPr>
           <a:lstStyle/>
@@ -4849,7 +4876,7 @@
           <a:noFill/>
         </p:spPr>
         <p:txBody>
-          <a:bodyPr wrap="square" anchor="t" lIns="0" rIns="0" tIns="0" bIns="0">
+          <a:bodyPr wrap="square" lIns="0" tIns="0" rIns="0" bIns="0" anchor="t">
             <a:spAutoFit/>
           </a:bodyPr>
           <a:lstStyle/>
@@ -4884,7 +4911,7 @@
           <a:noFill/>
         </p:spPr>
         <p:txBody>
-          <a:bodyPr wrap="square" anchor="t" lIns="0" rIns="0" tIns="0" bIns="0">
+          <a:bodyPr wrap="square" lIns="0" tIns="0" rIns="0" bIns="0" anchor="t">
             <a:spAutoFit/>
           </a:bodyPr>
           <a:lstStyle/>
@@ -4919,7 +4946,7 @@
           <a:noFill/>
         </p:spPr>
         <p:txBody>
-          <a:bodyPr wrap="square" anchor="t" lIns="0" rIns="0" tIns="0" bIns="0">
+          <a:bodyPr wrap="square" lIns="0" tIns="0" rIns="0" bIns="0" anchor="t">
             <a:spAutoFit/>
           </a:bodyPr>
           <a:lstStyle/>
@@ -4954,7 +4981,7 @@
           <a:noFill/>
         </p:spPr>
         <p:txBody>
-          <a:bodyPr wrap="square" anchor="t" lIns="0" rIns="0" tIns="0" bIns="0">
+          <a:bodyPr wrap="square" lIns="0" tIns="0" rIns="0" bIns="0" anchor="t">
             <a:spAutoFit/>
           </a:bodyPr>
           <a:lstStyle/>
@@ -4989,7 +5016,7 @@
           <a:noFill/>
         </p:spPr>
         <p:txBody>
-          <a:bodyPr wrap="square" anchor="t" lIns="0" rIns="0" tIns="0" bIns="0">
+          <a:bodyPr wrap="square" lIns="0" tIns="0" rIns="0" bIns="0" anchor="t">
             <a:spAutoFit/>
           </a:bodyPr>
           <a:lstStyle/>
@@ -5024,7 +5051,7 @@
           <a:noFill/>
         </p:spPr>
         <p:txBody>
-          <a:bodyPr wrap="square" anchor="t" lIns="0" rIns="0" tIns="0" bIns="0">
+          <a:bodyPr wrap="square" lIns="0" tIns="0" rIns="0" bIns="0" anchor="t">
             <a:spAutoFit/>
           </a:bodyPr>
           <a:lstStyle/>
@@ -5059,7 +5086,7 @@
           <a:noFill/>
         </p:spPr>
         <p:txBody>
-          <a:bodyPr wrap="square" anchor="t" lIns="0" rIns="0" tIns="0" bIns="0">
+          <a:bodyPr wrap="square" lIns="0" tIns="0" rIns="0" bIns="0" anchor="t">
             <a:spAutoFit/>
           </a:bodyPr>
           <a:lstStyle/>
@@ -5086,7 +5113,7 @@
 </file>
 
 <file path=ppt/slides/slide11.xml><?xml version="1.0" encoding="utf-8"?>
-<p:sld xmlns:a="http://schemas.openxmlformats.org/drawingml/2006/main" xmlns:p="http://schemas.openxmlformats.org/presentationml/2006/main" xmlns:r="http://schemas.openxmlformats.org/officeDocument/2006/relationships">
+<p:sld xmlns:a="http://schemas.openxmlformats.org/drawingml/2006/main" xmlns:r="http://schemas.openxmlformats.org/officeDocument/2006/relationships" xmlns:p="http://schemas.openxmlformats.org/presentationml/2006/main">
   <p:cSld>
     <p:spTree>
       <p:nvGrpSpPr>
@@ -5094,7 +5121,14 @@
         <p:cNvGrpSpPr/>
         <p:nvPr/>
       </p:nvGrpSpPr>
-      <p:grpSpPr/>
+      <p:grpSpPr>
+        <a:xfrm>
+          <a:off x="0" y="0"/>
+          <a:ext cx="0" cy="0"/>
+          <a:chOff x="0" y="0"/>
+          <a:chExt cx="0" cy="0"/>
+        </a:xfrm>
+      </p:grpSpPr>
       <p:sp>
         <p:nvSpPr>
           <p:cNvPr id="2" name="Rectangle 1"/>
@@ -5135,6 +5169,7 @@
           <a:lstStyle/>
           <a:p>
             <a:pPr algn="ctr"/>
+            <a:endParaRPr/>
           </a:p>
         </p:txBody>
       </p:sp>
@@ -5178,6 +5213,7 @@
           <a:lstStyle/>
           <a:p>
             <a:pPr algn="ctr"/>
+            <a:endParaRPr/>
           </a:p>
         </p:txBody>
       </p:sp>
@@ -5217,7 +5253,7 @@
           </a:fontRef>
         </p:style>
         <p:txBody>
-          <a:bodyPr rtlCol="0" anchor="ctr" lIns="0" rIns="0" tIns="0" bIns="0"/>
+          <a:bodyPr lIns="0" tIns="0" rIns="0" bIns="0" rtlCol="0" anchor="ctr"/>
           <a:lstStyle/>
           <a:p>
             <a:pPr algn="ctr"/>
@@ -5250,7 +5286,7 @@
           <a:noFill/>
         </p:spPr>
         <p:txBody>
-          <a:bodyPr wrap="square" anchor="t" lIns="0" rIns="0" tIns="0" bIns="0">
+          <a:bodyPr wrap="square" lIns="0" tIns="0" rIns="0" bIns="0" anchor="t">
             <a:spAutoFit/>
           </a:bodyPr>
           <a:lstStyle/>
@@ -5285,7 +5321,7 @@
           <a:noFill/>
         </p:spPr>
         <p:txBody>
-          <a:bodyPr wrap="square" anchor="t" lIns="0" rIns="0" tIns="0" bIns="0">
+          <a:bodyPr wrap="square" lIns="0" tIns="0" rIns="0" bIns="0" anchor="t">
             <a:spAutoFit/>
           </a:bodyPr>
           <a:lstStyle/>
@@ -5320,7 +5356,7 @@
           <a:noFill/>
         </p:spPr>
         <p:txBody>
-          <a:bodyPr wrap="square" anchor="t" lIns="0" rIns="0" tIns="0" bIns="0">
+          <a:bodyPr wrap="square" lIns="0" tIns="0" rIns="0" bIns="0" anchor="t">
             <a:spAutoFit/>
           </a:bodyPr>
           <a:lstStyle/>
@@ -5355,7 +5391,7 @@
           <a:noFill/>
         </p:spPr>
         <p:txBody>
-          <a:bodyPr wrap="square" anchor="t" lIns="0" rIns="0" tIns="0" bIns="0">
+          <a:bodyPr wrap="square" lIns="0" tIns="0" rIns="0" bIns="0" anchor="t">
             <a:spAutoFit/>
           </a:bodyPr>
           <a:lstStyle/>
@@ -5415,6 +5451,7 @@
           <a:lstStyle/>
           <a:p>
             <a:pPr algn="ctr"/>
+            <a:endParaRPr/>
           </a:p>
         </p:txBody>
       </p:sp>
@@ -5435,7 +5472,7 @@
           <a:noFill/>
         </p:spPr>
         <p:txBody>
-          <a:bodyPr wrap="square" anchor="t" lIns="0" rIns="0" tIns="0" bIns="0">
+          <a:bodyPr wrap="square" lIns="0" tIns="0" rIns="0" bIns="0" anchor="t">
             <a:spAutoFit/>
           </a:bodyPr>
           <a:lstStyle/>
@@ -5470,7 +5507,7 @@
           <a:noFill/>
         </p:spPr>
         <p:txBody>
-          <a:bodyPr wrap="square" anchor="t" lIns="0" rIns="0" tIns="0" bIns="0">
+          <a:bodyPr wrap="square" lIns="0" tIns="0" rIns="0" bIns="0" anchor="t">
             <a:spAutoFit/>
           </a:bodyPr>
           <a:lstStyle/>
@@ -5505,7 +5542,7 @@
           <a:noFill/>
         </p:spPr>
         <p:txBody>
-          <a:bodyPr wrap="square" anchor="t" lIns="0" rIns="0" tIns="0" bIns="0">
+          <a:bodyPr wrap="square" lIns="0" tIns="0" rIns="0" bIns="0" anchor="t">
             <a:spAutoFit/>
           </a:bodyPr>
           <a:lstStyle/>
@@ -5540,7 +5577,7 @@
           <a:noFill/>
         </p:spPr>
         <p:txBody>
-          <a:bodyPr wrap="square" anchor="t" lIns="0" rIns="0" tIns="0" bIns="0">
+          <a:bodyPr wrap="square" lIns="0" tIns="0" rIns="0" bIns="0" anchor="t">
             <a:spAutoFit/>
           </a:bodyPr>
           <a:lstStyle/>
@@ -5600,6 +5637,7 @@
           <a:lstStyle/>
           <a:p>
             <a:pPr algn="ctr"/>
+            <a:endParaRPr/>
           </a:p>
         </p:txBody>
       </p:sp>
@@ -5620,7 +5658,7 @@
           <a:noFill/>
         </p:spPr>
         <p:txBody>
-          <a:bodyPr wrap="square" anchor="t" lIns="0" rIns="0" tIns="0" bIns="0">
+          <a:bodyPr wrap="square" lIns="0" tIns="0" rIns="0" bIns="0" anchor="t">
             <a:spAutoFit/>
           </a:bodyPr>
           <a:lstStyle/>
@@ -5655,7 +5693,7 @@
           <a:noFill/>
         </p:spPr>
         <p:txBody>
-          <a:bodyPr wrap="square" anchor="t" lIns="0" rIns="0" tIns="0" bIns="0">
+          <a:bodyPr wrap="square" lIns="0" tIns="0" rIns="0" bIns="0" anchor="t">
             <a:spAutoFit/>
           </a:bodyPr>
           <a:lstStyle/>
@@ -5690,7 +5728,7 @@
           <a:noFill/>
         </p:spPr>
         <p:txBody>
-          <a:bodyPr wrap="square" anchor="t" lIns="0" rIns="0" tIns="0" bIns="0">
+          <a:bodyPr wrap="square" lIns="0" tIns="0" rIns="0" bIns="0" anchor="t">
             <a:spAutoFit/>
           </a:bodyPr>
           <a:lstStyle/>
@@ -5725,7 +5763,7 @@
           <a:noFill/>
         </p:spPr>
         <p:txBody>
-          <a:bodyPr wrap="square" anchor="t" lIns="0" rIns="0" tIns="0" bIns="0">
+          <a:bodyPr wrap="square" lIns="0" tIns="0" rIns="0" bIns="0" anchor="t">
             <a:spAutoFit/>
           </a:bodyPr>
           <a:lstStyle/>
@@ -5785,6 +5823,7 @@
           <a:lstStyle/>
           <a:p>
             <a:pPr algn="ctr"/>
+            <a:endParaRPr/>
           </a:p>
         </p:txBody>
       </p:sp>
@@ -5805,7 +5844,7 @@
           <a:noFill/>
         </p:spPr>
         <p:txBody>
-          <a:bodyPr wrap="square" anchor="t" lIns="0" rIns="0" tIns="0" bIns="0">
+          <a:bodyPr wrap="square" lIns="0" tIns="0" rIns="0" bIns="0" anchor="t">
             <a:spAutoFit/>
           </a:bodyPr>
           <a:lstStyle/>
@@ -5840,7 +5879,7 @@
           <a:noFill/>
         </p:spPr>
         <p:txBody>
-          <a:bodyPr wrap="square" anchor="t" lIns="0" rIns="0" tIns="0" bIns="0">
+          <a:bodyPr wrap="square" lIns="0" tIns="0" rIns="0" bIns="0" anchor="t">
             <a:spAutoFit/>
           </a:bodyPr>
           <a:lstStyle/>
@@ -5875,7 +5914,7 @@
           <a:noFill/>
         </p:spPr>
         <p:txBody>
-          <a:bodyPr wrap="square" anchor="t" lIns="0" rIns="0" tIns="0" bIns="0">
+          <a:bodyPr wrap="square" lIns="0" tIns="0" rIns="0" bIns="0" anchor="t">
             <a:spAutoFit/>
           </a:bodyPr>
           <a:lstStyle/>
@@ -5910,7 +5949,7 @@
           <a:noFill/>
         </p:spPr>
         <p:txBody>
-          <a:bodyPr wrap="square" anchor="t" lIns="0" rIns="0" tIns="0" bIns="0">
+          <a:bodyPr wrap="square" lIns="0" tIns="0" rIns="0" bIns="0" anchor="t">
             <a:spAutoFit/>
           </a:bodyPr>
           <a:lstStyle/>
@@ -5970,6 +6009,7 @@
           <a:lstStyle/>
           <a:p>
             <a:pPr algn="ctr"/>
+            <a:endParaRPr/>
           </a:p>
         </p:txBody>
       </p:sp>
@@ -5990,7 +6030,7 @@
           <a:noFill/>
         </p:spPr>
         <p:txBody>
-          <a:bodyPr wrap="square" anchor="t" lIns="0" rIns="0" tIns="0" bIns="0">
+          <a:bodyPr wrap="square" lIns="0" tIns="0" rIns="0" bIns="0" anchor="t">
             <a:spAutoFit/>
           </a:bodyPr>
           <a:lstStyle/>
@@ -6025,7 +6065,7 @@
           <a:noFill/>
         </p:spPr>
         <p:txBody>
-          <a:bodyPr wrap="square" anchor="t" lIns="0" rIns="0" tIns="0" bIns="0">
+          <a:bodyPr wrap="square" lIns="0" tIns="0" rIns="0" bIns="0" anchor="t">
             <a:spAutoFit/>
           </a:bodyPr>
           <a:lstStyle/>
@@ -6060,7 +6100,7 @@
           <a:noFill/>
         </p:spPr>
         <p:txBody>
-          <a:bodyPr wrap="square" anchor="t" lIns="0" rIns="0" tIns="0" bIns="0">
+          <a:bodyPr wrap="square" lIns="0" tIns="0" rIns="0" bIns="0" anchor="t">
             <a:spAutoFit/>
           </a:bodyPr>
           <a:lstStyle/>
@@ -6095,7 +6135,7 @@
           <a:noFill/>
         </p:spPr>
         <p:txBody>
-          <a:bodyPr wrap="square" anchor="t" lIns="0" rIns="0" tIns="0" bIns="0">
+          <a:bodyPr wrap="square" lIns="0" tIns="0" rIns="0" bIns="0" anchor="t">
             <a:spAutoFit/>
           </a:bodyPr>
           <a:lstStyle/>
@@ -6130,7 +6170,7 @@
           <a:noFill/>
         </p:spPr>
         <p:txBody>
-          <a:bodyPr wrap="square" anchor="t" lIns="0" rIns="0" tIns="0" bIns="0">
+          <a:bodyPr wrap="square" lIns="0" tIns="0" rIns="0" bIns="0" anchor="t">
             <a:spAutoFit/>
           </a:bodyPr>
           <a:lstStyle/>
@@ -6165,7 +6205,7 @@
           <a:noFill/>
         </p:spPr>
         <p:txBody>
-          <a:bodyPr wrap="square" anchor="t" lIns="0" rIns="0" tIns="0" bIns="0">
+          <a:bodyPr wrap="square" lIns="0" tIns="0" rIns="0" bIns="0" anchor="t">
             <a:spAutoFit/>
           </a:bodyPr>
           <a:lstStyle/>
@@ -6200,7 +6240,7 @@
           <a:noFill/>
         </p:spPr>
         <p:txBody>
-          <a:bodyPr wrap="square" anchor="t" lIns="0" rIns="0" tIns="0" bIns="0">
+          <a:bodyPr wrap="square" lIns="0" tIns="0" rIns="0" bIns="0" anchor="t">
             <a:spAutoFit/>
           </a:bodyPr>
           <a:lstStyle/>
@@ -6235,7 +6275,7 @@
           <a:noFill/>
         </p:spPr>
         <p:txBody>
-          <a:bodyPr wrap="square" anchor="t" lIns="0" rIns="0" tIns="0" bIns="0">
+          <a:bodyPr wrap="square" lIns="0" tIns="0" rIns="0" bIns="0" anchor="t">
             <a:spAutoFit/>
           </a:bodyPr>
           <a:lstStyle/>
@@ -6262,7 +6302,7 @@
 </file>
 
 <file path=ppt/slides/slide12.xml><?xml version="1.0" encoding="utf-8"?>
-<p:sld xmlns:a="http://schemas.openxmlformats.org/drawingml/2006/main" xmlns:p="http://schemas.openxmlformats.org/presentationml/2006/main" xmlns:r="http://schemas.openxmlformats.org/officeDocument/2006/relationships">
+<p:sld xmlns:a="http://schemas.openxmlformats.org/drawingml/2006/main" xmlns:r="http://schemas.openxmlformats.org/officeDocument/2006/relationships" xmlns:p="http://schemas.openxmlformats.org/presentationml/2006/main">
   <p:cSld>
     <p:spTree>
       <p:nvGrpSpPr>
@@ -6270,7 +6310,14 @@
         <p:cNvGrpSpPr/>
         <p:nvPr/>
       </p:nvGrpSpPr>
-      <p:grpSpPr/>
+      <p:grpSpPr>
+        <a:xfrm>
+          <a:off x="0" y="0"/>
+          <a:ext cx="0" cy="0"/>
+          <a:chOff x="0" y="0"/>
+          <a:chExt cx="0" cy="0"/>
+        </a:xfrm>
+      </p:grpSpPr>
       <p:sp>
         <p:nvSpPr>
           <p:cNvPr id="2" name="Rectangle 1"/>
@@ -6311,6 +6358,7 @@
           <a:lstStyle/>
           <a:p>
             <a:pPr algn="ctr"/>
+            <a:endParaRPr/>
           </a:p>
         </p:txBody>
       </p:sp>
@@ -6354,6 +6402,7 @@
           <a:lstStyle/>
           <a:p>
             <a:pPr algn="ctr"/>
+            <a:endParaRPr/>
           </a:p>
         </p:txBody>
       </p:sp>
@@ -6397,6 +6446,7 @@
           <a:lstStyle/>
           <a:p>
             <a:pPr algn="ctr"/>
+            <a:endParaRPr/>
           </a:p>
         </p:txBody>
       </p:sp>
@@ -6436,7 +6486,7 @@
           </a:fontRef>
         </p:style>
         <p:txBody>
-          <a:bodyPr rtlCol="0" anchor="ctr" lIns="0" rIns="0" tIns="0" bIns="0"/>
+          <a:bodyPr lIns="0" tIns="0" rIns="0" bIns="0" rtlCol="0" anchor="ctr"/>
           <a:lstStyle/>
           <a:p>
             <a:pPr algn="ctr"/>
@@ -6468,7 +6518,7 @@
           <a:noFill/>
         </p:spPr>
         <p:txBody>
-          <a:bodyPr wrap="square" anchor="t" lIns="0" rIns="0" tIns="0" bIns="0">
+          <a:bodyPr wrap="square" lIns="0" tIns="0" rIns="0" bIns="0" anchor="t">
             <a:spAutoFit/>
           </a:bodyPr>
           <a:lstStyle/>
@@ -6503,7 +6553,7 @@
           <a:noFill/>
         </p:spPr>
         <p:txBody>
-          <a:bodyPr wrap="square" anchor="t" lIns="0" rIns="0" tIns="0" bIns="0">
+          <a:bodyPr wrap="square" lIns="0" tIns="0" rIns="0" bIns="0" anchor="t">
             <a:spAutoFit/>
           </a:bodyPr>
           <a:lstStyle/>
@@ -6538,7 +6588,7 @@
           <a:noFill/>
         </p:spPr>
         <p:txBody>
-          <a:bodyPr wrap="square" anchor="t" lIns="0" rIns="0" tIns="0" bIns="0">
+          <a:bodyPr wrap="square" lIns="0" tIns="0" rIns="0" bIns="0" anchor="t">
             <a:spAutoFit/>
           </a:bodyPr>
           <a:lstStyle/>
@@ -6573,7 +6623,7 @@
           <a:noFill/>
         </p:spPr>
         <p:txBody>
-          <a:bodyPr wrap="square" anchor="t" lIns="0" rIns="0" tIns="0" bIns="0">
+          <a:bodyPr wrap="square" lIns="0" tIns="0" rIns="0" bIns="0" anchor="t">
             <a:spAutoFit/>
           </a:bodyPr>
           <a:lstStyle/>
@@ -6608,7 +6658,7 @@
           <a:noFill/>
         </p:spPr>
         <p:txBody>
-          <a:bodyPr wrap="square" anchor="t" lIns="0" rIns="0" tIns="0" bIns="0">
+          <a:bodyPr wrap="square" lIns="0" tIns="0" rIns="0" bIns="0" anchor="t">
             <a:spAutoFit/>
           </a:bodyPr>
           <a:lstStyle/>
@@ -6666,6 +6716,7 @@
           <a:lstStyle/>
           <a:p>
             <a:pPr algn="ctr"/>
+            <a:endParaRPr/>
           </a:p>
         </p:txBody>
       </p:sp>
@@ -6686,7 +6737,7 @@
           <a:noFill/>
         </p:spPr>
         <p:txBody>
-          <a:bodyPr wrap="square" anchor="t" lIns="0" rIns="0" tIns="0" bIns="0">
+          <a:bodyPr wrap="square" lIns="0" tIns="0" rIns="0" bIns="0" anchor="t">
             <a:spAutoFit/>
           </a:bodyPr>
           <a:lstStyle/>
@@ -6713,7 +6764,7 @@
 </file>
 
 <file path=ppt/slides/slide2.xml><?xml version="1.0" encoding="utf-8"?>
-<p:sld xmlns:a="http://schemas.openxmlformats.org/drawingml/2006/main" xmlns:p="http://schemas.openxmlformats.org/presentationml/2006/main" xmlns:r="http://schemas.openxmlformats.org/officeDocument/2006/relationships">
+<p:sld xmlns:a="http://schemas.openxmlformats.org/drawingml/2006/main" xmlns:r="http://schemas.openxmlformats.org/officeDocument/2006/relationships" xmlns:p="http://schemas.openxmlformats.org/presentationml/2006/main">
   <p:cSld>
     <p:spTree>
       <p:nvGrpSpPr>
@@ -6721,7 +6772,14 @@
         <p:cNvGrpSpPr/>
         <p:nvPr/>
       </p:nvGrpSpPr>
-      <p:grpSpPr/>
+      <p:grpSpPr>
+        <a:xfrm>
+          <a:off x="0" y="0"/>
+          <a:ext cx="0" cy="0"/>
+          <a:chOff x="0" y="0"/>
+          <a:chExt cx="0" cy="0"/>
+        </a:xfrm>
+      </p:grpSpPr>
       <p:sp>
         <p:nvSpPr>
           <p:cNvPr id="2" name="Rectangle 1"/>
@@ -6762,6 +6820,7 @@
           <a:lstStyle/>
           <a:p>
             <a:pPr algn="ctr"/>
+            <a:endParaRPr/>
           </a:p>
         </p:txBody>
       </p:sp>
@@ -6805,6 +6864,7 @@
           <a:lstStyle/>
           <a:p>
             <a:pPr algn="ctr"/>
+            <a:endParaRPr/>
           </a:p>
         </p:txBody>
       </p:sp>
@@ -6844,7 +6904,7 @@
           </a:fontRef>
         </p:style>
         <p:txBody>
-          <a:bodyPr rtlCol="0" anchor="ctr" lIns="0" rIns="0" tIns="0" bIns="0"/>
+          <a:bodyPr lIns="0" tIns="0" rIns="0" bIns="0" rtlCol="0" anchor="ctr"/>
           <a:lstStyle/>
           <a:p>
             <a:pPr algn="ctr"/>
@@ -6877,7 +6937,7 @@
           <a:noFill/>
         </p:spPr>
         <p:txBody>
-          <a:bodyPr wrap="square" anchor="t" lIns="0" rIns="0" tIns="0" bIns="0">
+          <a:bodyPr wrap="square" lIns="0" tIns="0" rIns="0" bIns="0" anchor="t">
             <a:spAutoFit/>
           </a:bodyPr>
           <a:lstStyle/>
@@ -6912,7 +6972,7 @@
           <a:noFill/>
         </p:spPr>
         <p:txBody>
-          <a:bodyPr wrap="square" anchor="t" lIns="0" rIns="0" tIns="0" bIns="0">
+          <a:bodyPr wrap="square" lIns="0" tIns="0" rIns="0" bIns="0" anchor="t">
             <a:spAutoFit/>
           </a:bodyPr>
           <a:lstStyle/>
@@ -6947,7 +7007,7 @@
           <a:noFill/>
         </p:spPr>
         <p:txBody>
-          <a:bodyPr wrap="square" anchor="t" lIns="0" rIns="0" tIns="0" bIns="0">
+          <a:bodyPr wrap="square" lIns="0" tIns="0" rIns="0" bIns="0" anchor="t">
             <a:spAutoFit/>
           </a:bodyPr>
           <a:lstStyle/>
@@ -6982,7 +7042,7 @@
           <a:noFill/>
         </p:spPr>
         <p:txBody>
-          <a:bodyPr wrap="square" anchor="t" lIns="0" rIns="0" tIns="0" bIns="0">
+          <a:bodyPr wrap="square" lIns="0" tIns="0" rIns="0" bIns="0" anchor="t">
             <a:spAutoFit/>
           </a:bodyPr>
           <a:lstStyle/>
@@ -7017,7 +7077,7 @@
           <a:noFill/>
         </p:spPr>
         <p:txBody>
-          <a:bodyPr wrap="square" anchor="t" lIns="0" rIns="0" tIns="0" bIns="0">
+          <a:bodyPr wrap="square" lIns="0" tIns="0" rIns="0" bIns="0" anchor="t">
             <a:spAutoFit/>
           </a:bodyPr>
           <a:lstStyle/>
@@ -7077,6 +7137,7 @@
           <a:lstStyle/>
           <a:p>
             <a:pPr algn="ctr"/>
+            <a:endParaRPr/>
           </a:p>
         </p:txBody>
       </p:sp>
@@ -7120,6 +7181,7 @@
           <a:lstStyle/>
           <a:p>
             <a:pPr algn="ctr"/>
+            <a:endParaRPr/>
           </a:p>
         </p:txBody>
       </p:sp>
@@ -7140,7 +7202,7 @@
           <a:noFill/>
         </p:spPr>
         <p:txBody>
-          <a:bodyPr wrap="square" anchor="t" lIns="0" rIns="0" tIns="0" bIns="0">
+          <a:bodyPr wrap="square" lIns="0" tIns="0" rIns="0" bIns="0" anchor="t">
             <a:spAutoFit/>
           </a:bodyPr>
           <a:lstStyle/>
@@ -7175,7 +7237,7 @@
           <a:noFill/>
         </p:spPr>
         <p:txBody>
-          <a:bodyPr wrap="square" anchor="t" lIns="0" rIns="0" tIns="0" bIns="0">
+          <a:bodyPr wrap="square" lIns="0" tIns="0" rIns="0" bIns="0" anchor="t">
             <a:spAutoFit/>
           </a:bodyPr>
           <a:lstStyle/>
@@ -7210,7 +7272,7 @@
           <a:noFill/>
         </p:spPr>
         <p:txBody>
-          <a:bodyPr wrap="square" anchor="t" lIns="0" rIns="0" tIns="0" bIns="0">
+          <a:bodyPr wrap="square" lIns="0" tIns="0" rIns="0" bIns="0" anchor="t">
             <a:spAutoFit/>
           </a:bodyPr>
           <a:lstStyle/>
@@ -7271,6 +7333,7 @@
           <a:lstStyle/>
           <a:p>
             <a:pPr algn="ctr"/>
+            <a:endParaRPr/>
           </a:p>
         </p:txBody>
       </p:sp>
@@ -7314,6 +7377,7 @@
           <a:lstStyle/>
           <a:p>
             <a:pPr algn="ctr"/>
+            <a:endParaRPr/>
           </a:p>
         </p:txBody>
       </p:sp>
@@ -7334,7 +7398,7 @@
           <a:noFill/>
         </p:spPr>
         <p:txBody>
-          <a:bodyPr wrap="square" anchor="t" lIns="0" rIns="0" tIns="0" bIns="0">
+          <a:bodyPr wrap="square" lIns="0" tIns="0" rIns="0" bIns="0" anchor="t">
             <a:spAutoFit/>
           </a:bodyPr>
           <a:lstStyle/>
@@ -7369,7 +7433,7 @@
           <a:noFill/>
         </p:spPr>
         <p:txBody>
-          <a:bodyPr wrap="square" anchor="t" lIns="0" rIns="0" tIns="0" bIns="0">
+          <a:bodyPr wrap="square" lIns="0" tIns="0" rIns="0" bIns="0" anchor="t">
             <a:spAutoFit/>
           </a:bodyPr>
           <a:lstStyle/>
@@ -7404,7 +7468,7 @@
           <a:noFill/>
         </p:spPr>
         <p:txBody>
-          <a:bodyPr wrap="square" anchor="t" lIns="0" rIns="0" tIns="0" bIns="0">
+          <a:bodyPr wrap="square" lIns="0" tIns="0" rIns="0" bIns="0" anchor="t">
             <a:spAutoFit/>
           </a:bodyPr>
           <a:lstStyle/>
@@ -7465,6 +7529,7 @@
           <a:lstStyle/>
           <a:p>
             <a:pPr algn="ctr"/>
+            <a:endParaRPr/>
           </a:p>
         </p:txBody>
       </p:sp>
@@ -7508,6 +7573,7 @@
           <a:lstStyle/>
           <a:p>
             <a:pPr algn="ctr"/>
+            <a:endParaRPr/>
           </a:p>
         </p:txBody>
       </p:sp>
@@ -7528,7 +7594,7 @@
           <a:noFill/>
         </p:spPr>
         <p:txBody>
-          <a:bodyPr wrap="square" anchor="t" lIns="0" rIns="0" tIns="0" bIns="0">
+          <a:bodyPr wrap="square" lIns="0" tIns="0" rIns="0" bIns="0" anchor="t">
             <a:spAutoFit/>
           </a:bodyPr>
           <a:lstStyle/>
@@ -7563,7 +7629,7 @@
           <a:noFill/>
         </p:spPr>
         <p:txBody>
-          <a:bodyPr wrap="square" anchor="t" lIns="0" rIns="0" tIns="0" bIns="0">
+          <a:bodyPr wrap="square" lIns="0" tIns="0" rIns="0" bIns="0" anchor="t">
             <a:spAutoFit/>
           </a:bodyPr>
           <a:lstStyle/>
@@ -7598,7 +7664,7 @@
           <a:noFill/>
         </p:spPr>
         <p:txBody>
-          <a:bodyPr wrap="square" anchor="t" lIns="0" rIns="0" tIns="0" bIns="0">
+          <a:bodyPr wrap="square" lIns="0" tIns="0" rIns="0" bIns="0" anchor="t">
             <a:spAutoFit/>
           </a:bodyPr>
           <a:lstStyle/>
@@ -7634,7 +7700,7 @@
           <a:noFill/>
         </p:spPr>
         <p:txBody>
-          <a:bodyPr wrap="square" anchor="t" lIns="0" rIns="0" tIns="0" bIns="0">
+          <a:bodyPr wrap="square" lIns="0" tIns="0" rIns="0" bIns="0" anchor="t">
             <a:spAutoFit/>
           </a:bodyPr>
           <a:lstStyle/>
@@ -7669,7 +7735,7 @@
           <a:noFill/>
         </p:spPr>
         <p:txBody>
-          <a:bodyPr wrap="square" anchor="t" lIns="0" rIns="0" tIns="0" bIns="0">
+          <a:bodyPr wrap="square" lIns="0" tIns="0" rIns="0" bIns="0" anchor="t">
             <a:spAutoFit/>
           </a:bodyPr>
           <a:lstStyle/>
@@ -7704,7 +7770,7 @@
           <a:noFill/>
         </p:spPr>
         <p:txBody>
-          <a:bodyPr wrap="square" anchor="t" lIns="0" rIns="0" tIns="0" bIns="0">
+          <a:bodyPr wrap="square" lIns="0" tIns="0" rIns="0" bIns="0" anchor="t">
             <a:spAutoFit/>
           </a:bodyPr>
           <a:lstStyle/>
@@ -7731,7 +7797,7 @@
 </file>
 
 <file path=ppt/slides/slide3.xml><?xml version="1.0" encoding="utf-8"?>
-<p:sld xmlns:a="http://schemas.openxmlformats.org/drawingml/2006/main" xmlns:p="http://schemas.openxmlformats.org/presentationml/2006/main" xmlns:r="http://schemas.openxmlformats.org/officeDocument/2006/relationships">
+<p:sld xmlns:a="http://schemas.openxmlformats.org/drawingml/2006/main" xmlns:r="http://schemas.openxmlformats.org/officeDocument/2006/relationships" xmlns:p="http://schemas.openxmlformats.org/presentationml/2006/main">
   <p:cSld>
     <p:spTree>
       <p:nvGrpSpPr>
@@ -7739,7 +7805,14 @@
         <p:cNvGrpSpPr/>
         <p:nvPr/>
       </p:nvGrpSpPr>
-      <p:grpSpPr/>
+      <p:grpSpPr>
+        <a:xfrm>
+          <a:off x="0" y="0"/>
+          <a:ext cx="0" cy="0"/>
+          <a:chOff x="0" y="0"/>
+          <a:chExt cx="0" cy="0"/>
+        </a:xfrm>
+      </p:grpSpPr>
       <p:sp>
         <p:nvSpPr>
           <p:cNvPr id="2" name="Rectangle 1"/>
@@ -7780,6 +7853,7 @@
           <a:lstStyle/>
           <a:p>
             <a:pPr algn="ctr"/>
+            <a:endParaRPr/>
           </a:p>
         </p:txBody>
       </p:sp>
@@ -7823,6 +7897,7 @@
           <a:lstStyle/>
           <a:p>
             <a:pPr algn="ctr"/>
+            <a:endParaRPr/>
           </a:p>
         </p:txBody>
       </p:sp>
@@ -7862,7 +7937,7 @@
           </a:fontRef>
         </p:style>
         <p:txBody>
-          <a:bodyPr rtlCol="0" anchor="ctr" lIns="0" rIns="0" tIns="0" bIns="0"/>
+          <a:bodyPr lIns="0" tIns="0" rIns="0" bIns="0" rtlCol="0" anchor="ctr"/>
           <a:lstStyle/>
           <a:p>
             <a:pPr algn="ctr"/>
@@ -7895,7 +7970,7 @@
           <a:noFill/>
         </p:spPr>
         <p:txBody>
-          <a:bodyPr wrap="square" anchor="t" lIns="0" rIns="0" tIns="0" bIns="0">
+          <a:bodyPr wrap="square" lIns="0" tIns="0" rIns="0" bIns="0" anchor="t">
             <a:spAutoFit/>
           </a:bodyPr>
           <a:lstStyle/>
@@ -7930,7 +8005,7 @@
           <a:noFill/>
         </p:spPr>
         <p:txBody>
-          <a:bodyPr wrap="square" anchor="t" lIns="0" rIns="0" tIns="0" bIns="0">
+          <a:bodyPr wrap="square" lIns="0" tIns="0" rIns="0" bIns="0" anchor="t">
             <a:spAutoFit/>
           </a:bodyPr>
           <a:lstStyle/>
@@ -7965,7 +8040,7 @@
           <a:noFill/>
         </p:spPr>
         <p:txBody>
-          <a:bodyPr wrap="square" anchor="t" lIns="0" rIns="0" tIns="0" bIns="0">
+          <a:bodyPr wrap="square" lIns="0" tIns="0" rIns="0" bIns="0" anchor="t">
             <a:spAutoFit/>
           </a:bodyPr>
           <a:lstStyle/>
@@ -8000,7 +8075,7 @@
           <a:noFill/>
         </p:spPr>
         <p:txBody>
-          <a:bodyPr wrap="square" anchor="t" lIns="0" rIns="0" tIns="0" bIns="0">
+          <a:bodyPr wrap="square" lIns="0" tIns="0" rIns="0" bIns="0" anchor="t">
             <a:spAutoFit/>
           </a:bodyPr>
           <a:lstStyle/>
@@ -8035,7 +8110,7 @@
           <a:noFill/>
         </p:spPr>
         <p:txBody>
-          <a:bodyPr wrap="square" anchor="t" lIns="0" rIns="0" tIns="0" bIns="0">
+          <a:bodyPr wrap="square" lIns="0" tIns="0" rIns="0" bIns="0" anchor="t">
             <a:spAutoFit/>
           </a:bodyPr>
           <a:lstStyle/>
@@ -8095,6 +8170,7 @@
           <a:lstStyle/>
           <a:p>
             <a:pPr algn="ctr"/>
+            <a:endParaRPr/>
           </a:p>
         </p:txBody>
       </p:sp>
@@ -8138,6 +8214,7 @@
           <a:lstStyle/>
           <a:p>
             <a:pPr algn="ctr"/>
+            <a:endParaRPr/>
           </a:p>
         </p:txBody>
       </p:sp>
@@ -8158,7 +8235,7 @@
           <a:noFill/>
         </p:spPr>
         <p:txBody>
-          <a:bodyPr wrap="square" anchor="t" lIns="0" rIns="0" tIns="0" bIns="0">
+          <a:bodyPr wrap="square" lIns="0" tIns="0" rIns="0" bIns="0" anchor="t">
             <a:spAutoFit/>
           </a:bodyPr>
           <a:lstStyle/>
@@ -8193,7 +8270,7 @@
           <a:noFill/>
         </p:spPr>
         <p:txBody>
-          <a:bodyPr wrap="square" anchor="t" lIns="0" rIns="0" tIns="0" bIns="0">
+          <a:bodyPr wrap="square" lIns="0" tIns="0" rIns="0" bIns="0" anchor="t">
             <a:spAutoFit/>
           </a:bodyPr>
           <a:lstStyle/>
@@ -8254,6 +8331,7 @@
           <a:lstStyle/>
           <a:p>
             <a:pPr algn="ctr"/>
+            <a:endParaRPr/>
           </a:p>
         </p:txBody>
       </p:sp>
@@ -8297,6 +8375,7 @@
           <a:lstStyle/>
           <a:p>
             <a:pPr algn="ctr"/>
+            <a:endParaRPr/>
           </a:p>
         </p:txBody>
       </p:sp>
@@ -8317,7 +8396,7 @@
           <a:noFill/>
         </p:spPr>
         <p:txBody>
-          <a:bodyPr wrap="square" anchor="t" lIns="0" rIns="0" tIns="0" bIns="0">
+          <a:bodyPr wrap="square" lIns="0" tIns="0" rIns="0" bIns="0" anchor="t">
             <a:spAutoFit/>
           </a:bodyPr>
           <a:lstStyle/>
@@ -8352,7 +8431,7 @@
           <a:noFill/>
         </p:spPr>
         <p:txBody>
-          <a:bodyPr wrap="square" anchor="t" lIns="0" rIns="0" tIns="0" bIns="0">
+          <a:bodyPr wrap="square" lIns="0" tIns="0" rIns="0" bIns="0" anchor="t">
             <a:spAutoFit/>
           </a:bodyPr>
           <a:lstStyle/>
@@ -8413,6 +8492,7 @@
           <a:lstStyle/>
           <a:p>
             <a:pPr algn="ctr"/>
+            <a:endParaRPr/>
           </a:p>
         </p:txBody>
       </p:sp>
@@ -8456,6 +8536,7 @@
           <a:lstStyle/>
           <a:p>
             <a:pPr algn="ctr"/>
+            <a:endParaRPr/>
           </a:p>
         </p:txBody>
       </p:sp>
@@ -8476,7 +8557,7 @@
           <a:noFill/>
         </p:spPr>
         <p:txBody>
-          <a:bodyPr wrap="square" anchor="t" lIns="0" rIns="0" tIns="0" bIns="0">
+          <a:bodyPr wrap="square" lIns="0" tIns="0" rIns="0" bIns="0" anchor="t">
             <a:spAutoFit/>
           </a:bodyPr>
           <a:lstStyle/>
@@ -8511,7 +8592,7 @@
           <a:noFill/>
         </p:spPr>
         <p:txBody>
-          <a:bodyPr wrap="square" anchor="t" lIns="0" rIns="0" tIns="0" bIns="0">
+          <a:bodyPr wrap="square" lIns="0" tIns="0" rIns="0" bIns="0" anchor="t">
             <a:spAutoFit/>
           </a:bodyPr>
           <a:lstStyle/>
@@ -8570,6 +8651,7 @@
           <a:lstStyle/>
           <a:p>
             <a:pPr algn="ctr"/>
+            <a:endParaRPr/>
           </a:p>
         </p:txBody>
       </p:sp>
@@ -8590,7 +8672,7 @@
           <a:noFill/>
         </p:spPr>
         <p:txBody>
-          <a:bodyPr wrap="square" anchor="t" lIns="0" rIns="0" tIns="0" bIns="0">
+          <a:bodyPr wrap="square" lIns="0" tIns="0" rIns="0" bIns="0" anchor="t">
             <a:spAutoFit/>
           </a:bodyPr>
           <a:lstStyle/>
@@ -8625,7 +8707,7 @@
           <a:noFill/>
         </p:spPr>
         <p:txBody>
-          <a:bodyPr wrap="square" anchor="t" lIns="0" rIns="0" tIns="0" bIns="0">
+          <a:bodyPr wrap="square" lIns="0" tIns="0" rIns="0" bIns="0" anchor="t">
             <a:spAutoFit/>
           </a:bodyPr>
           <a:lstStyle/>
@@ -8660,7 +8742,7 @@
           <a:noFill/>
         </p:spPr>
         <p:txBody>
-          <a:bodyPr wrap="square" anchor="t" lIns="0" rIns="0" tIns="0" bIns="0">
+          <a:bodyPr wrap="square" lIns="0" tIns="0" rIns="0" bIns="0" anchor="t">
             <a:spAutoFit/>
           </a:bodyPr>
           <a:lstStyle/>
@@ -8687,7 +8769,7 @@
 </file>
 
 <file path=ppt/slides/slide4.xml><?xml version="1.0" encoding="utf-8"?>
-<p:sld xmlns:a="http://schemas.openxmlformats.org/drawingml/2006/main" xmlns:p="http://schemas.openxmlformats.org/presentationml/2006/main" xmlns:r="http://schemas.openxmlformats.org/officeDocument/2006/relationships">
+<p:sld xmlns:a="http://schemas.openxmlformats.org/drawingml/2006/main" xmlns:r="http://schemas.openxmlformats.org/officeDocument/2006/relationships" xmlns:p="http://schemas.openxmlformats.org/presentationml/2006/main">
   <p:cSld>
     <p:spTree>
       <p:nvGrpSpPr>
@@ -8695,7 +8777,14 @@
         <p:cNvGrpSpPr/>
         <p:nvPr/>
       </p:nvGrpSpPr>
-      <p:grpSpPr/>
+      <p:grpSpPr>
+        <a:xfrm>
+          <a:off x="0" y="0"/>
+          <a:ext cx="0" cy="0"/>
+          <a:chOff x="0" y="0"/>
+          <a:chExt cx="0" cy="0"/>
+        </a:xfrm>
+      </p:grpSpPr>
       <p:sp>
         <p:nvSpPr>
           <p:cNvPr id="2" name="Rectangle 1"/>
@@ -8736,6 +8825,7 @@
           <a:lstStyle/>
           <a:p>
             <a:pPr algn="ctr"/>
+            <a:endParaRPr/>
           </a:p>
         </p:txBody>
       </p:sp>
@@ -8779,6 +8869,7 @@
           <a:lstStyle/>
           <a:p>
             <a:pPr algn="ctr"/>
+            <a:endParaRPr/>
           </a:p>
         </p:txBody>
       </p:sp>
@@ -8818,7 +8909,7 @@
           </a:fontRef>
         </p:style>
         <p:txBody>
-          <a:bodyPr rtlCol="0" anchor="ctr" lIns="0" rIns="0" tIns="0" bIns="0"/>
+          <a:bodyPr lIns="0" tIns="0" rIns="0" bIns="0" rtlCol="0" anchor="ctr"/>
           <a:lstStyle/>
           <a:p>
             <a:pPr algn="ctr"/>
@@ -8851,7 +8942,7 @@
           <a:noFill/>
         </p:spPr>
         <p:txBody>
-          <a:bodyPr wrap="square" anchor="t" lIns="0" rIns="0" tIns="0" bIns="0">
+          <a:bodyPr wrap="square" lIns="0" tIns="0" rIns="0" bIns="0" anchor="t">
             <a:spAutoFit/>
           </a:bodyPr>
           <a:lstStyle/>
@@ -8886,7 +8977,7 @@
           <a:noFill/>
         </p:spPr>
         <p:txBody>
-          <a:bodyPr wrap="square" anchor="t" lIns="0" rIns="0" tIns="0" bIns="0">
+          <a:bodyPr wrap="square" lIns="0" tIns="0" rIns="0" bIns="0" anchor="t">
             <a:spAutoFit/>
           </a:bodyPr>
           <a:lstStyle/>
@@ -8921,7 +9012,7 @@
           <a:noFill/>
         </p:spPr>
         <p:txBody>
-          <a:bodyPr wrap="square" anchor="t" lIns="0" rIns="0" tIns="0" bIns="0">
+          <a:bodyPr wrap="square" lIns="0" tIns="0" rIns="0" bIns="0" anchor="t">
             <a:spAutoFit/>
           </a:bodyPr>
           <a:lstStyle/>
@@ -8956,7 +9047,7 @@
           <a:noFill/>
         </p:spPr>
         <p:txBody>
-          <a:bodyPr wrap="square" anchor="t" lIns="0" rIns="0" tIns="0" bIns="0">
+          <a:bodyPr wrap="square" lIns="0" tIns="0" rIns="0" bIns="0" anchor="t">
             <a:spAutoFit/>
           </a:bodyPr>
           <a:lstStyle/>
@@ -8991,7 +9082,7 @@
           <a:noFill/>
         </p:spPr>
         <p:txBody>
-          <a:bodyPr wrap="square" anchor="t" lIns="0" rIns="0" tIns="0" bIns="0">
+          <a:bodyPr wrap="square" lIns="0" tIns="0" rIns="0" bIns="0" anchor="t">
             <a:spAutoFit/>
           </a:bodyPr>
           <a:lstStyle/>
@@ -9026,7 +9117,7 @@
           <a:noFill/>
         </p:spPr>
         <p:txBody>
-          <a:bodyPr wrap="square" anchor="t" lIns="0" rIns="0" tIns="0" bIns="0">
+          <a:bodyPr wrap="square" lIns="0" tIns="0" rIns="0" bIns="0" anchor="t">
             <a:spAutoFit/>
           </a:bodyPr>
           <a:lstStyle/>
@@ -9086,6 +9177,7 @@
           <a:lstStyle/>
           <a:p>
             <a:pPr algn="ctr"/>
+            <a:endParaRPr/>
           </a:p>
         </p:txBody>
       </p:sp>
@@ -9129,6 +9221,7 @@
           <a:lstStyle/>
           <a:p>
             <a:pPr algn="ctr"/>
+            <a:endParaRPr/>
           </a:p>
         </p:txBody>
       </p:sp>
@@ -9149,7 +9242,7 @@
           <a:noFill/>
         </p:spPr>
         <p:txBody>
-          <a:bodyPr wrap="square" anchor="t" lIns="0" rIns="0" tIns="0" bIns="0">
+          <a:bodyPr wrap="square" lIns="0" tIns="0" rIns="0" bIns="0" anchor="t">
             <a:spAutoFit/>
           </a:bodyPr>
           <a:lstStyle/>
@@ -9184,7 +9277,7 @@
           <a:noFill/>
         </p:spPr>
         <p:txBody>
-          <a:bodyPr wrap="square" anchor="t" lIns="0" rIns="0" tIns="0" bIns="0">
+          <a:bodyPr wrap="square" lIns="0" tIns="0" rIns="0" bIns="0" anchor="t">
             <a:spAutoFit/>
           </a:bodyPr>
           <a:lstStyle/>
@@ -9219,7 +9312,7 @@
           <a:noFill/>
         </p:spPr>
         <p:txBody>
-          <a:bodyPr wrap="square" anchor="t" lIns="0" rIns="0" tIns="0" bIns="0">
+          <a:bodyPr wrap="square" lIns="0" tIns="0" rIns="0" bIns="0" anchor="t">
             <a:spAutoFit/>
           </a:bodyPr>
           <a:lstStyle/>
@@ -9255,7 +9348,7 @@
           <a:noFill/>
         </p:spPr>
         <p:txBody>
-          <a:bodyPr wrap="square" anchor="t" lIns="0" rIns="0" tIns="0" bIns="0">
+          <a:bodyPr wrap="square" lIns="0" tIns="0" rIns="0" bIns="0" anchor="t">
             <a:spAutoFit/>
           </a:bodyPr>
           <a:lstStyle/>
@@ -9315,6 +9408,7 @@
           <a:lstStyle/>
           <a:p>
             <a:pPr algn="ctr"/>
+            <a:endParaRPr/>
           </a:p>
         </p:txBody>
       </p:sp>
@@ -9358,6 +9452,7 @@
           <a:lstStyle/>
           <a:p>
             <a:pPr algn="ctr"/>
+            <a:endParaRPr/>
           </a:p>
         </p:txBody>
       </p:sp>
@@ -9378,7 +9473,7 @@
           <a:noFill/>
         </p:spPr>
         <p:txBody>
-          <a:bodyPr wrap="square" anchor="t" lIns="0" rIns="0" tIns="0" bIns="0">
+          <a:bodyPr wrap="square" lIns="0" tIns="0" rIns="0" bIns="0" anchor="t">
             <a:spAutoFit/>
           </a:bodyPr>
           <a:lstStyle/>
@@ -9413,7 +9508,7 @@
           <a:noFill/>
         </p:spPr>
         <p:txBody>
-          <a:bodyPr wrap="square" anchor="t" lIns="0" rIns="0" tIns="0" bIns="0">
+          <a:bodyPr wrap="square" lIns="0" tIns="0" rIns="0" bIns="0" anchor="t">
             <a:spAutoFit/>
           </a:bodyPr>
           <a:lstStyle/>
@@ -9448,7 +9543,7 @@
           <a:noFill/>
         </p:spPr>
         <p:txBody>
-          <a:bodyPr wrap="square" anchor="t" lIns="0" rIns="0" tIns="0" bIns="0">
+          <a:bodyPr wrap="square" lIns="0" tIns="0" rIns="0" bIns="0" anchor="t">
             <a:spAutoFit/>
           </a:bodyPr>
           <a:lstStyle/>
@@ -9484,7 +9579,7 @@
           <a:noFill/>
         </p:spPr>
         <p:txBody>
-          <a:bodyPr wrap="square" anchor="t" lIns="0" rIns="0" tIns="0" bIns="0">
+          <a:bodyPr wrap="square" lIns="0" tIns="0" rIns="0" bIns="0" anchor="t">
             <a:spAutoFit/>
           </a:bodyPr>
           <a:lstStyle/>
@@ -9544,6 +9639,7 @@
           <a:lstStyle/>
           <a:p>
             <a:pPr algn="ctr"/>
+            <a:endParaRPr/>
           </a:p>
         </p:txBody>
       </p:sp>
@@ -9587,6 +9683,7 @@
           <a:lstStyle/>
           <a:p>
             <a:pPr algn="ctr"/>
+            <a:endParaRPr/>
           </a:p>
         </p:txBody>
       </p:sp>
@@ -9607,7 +9704,7 @@
           <a:noFill/>
         </p:spPr>
         <p:txBody>
-          <a:bodyPr wrap="square" anchor="t" lIns="0" rIns="0" tIns="0" bIns="0">
+          <a:bodyPr wrap="square" lIns="0" tIns="0" rIns="0" bIns="0" anchor="t">
             <a:spAutoFit/>
           </a:bodyPr>
           <a:lstStyle/>
@@ -9642,7 +9739,7 @@
           <a:noFill/>
         </p:spPr>
         <p:txBody>
-          <a:bodyPr wrap="square" anchor="t" lIns="0" rIns="0" tIns="0" bIns="0">
+          <a:bodyPr wrap="square" lIns="0" tIns="0" rIns="0" bIns="0" anchor="t">
             <a:spAutoFit/>
           </a:bodyPr>
           <a:lstStyle/>
@@ -9677,7 +9774,7 @@
           <a:noFill/>
         </p:spPr>
         <p:txBody>
-          <a:bodyPr wrap="square" anchor="t" lIns="0" rIns="0" tIns="0" bIns="0">
+          <a:bodyPr wrap="square" lIns="0" tIns="0" rIns="0" bIns="0" anchor="t">
             <a:spAutoFit/>
           </a:bodyPr>
           <a:lstStyle/>
@@ -9713,7 +9810,7 @@
           <a:noFill/>
         </p:spPr>
         <p:txBody>
-          <a:bodyPr wrap="square" anchor="t" lIns="0" rIns="0" tIns="0" bIns="0">
+          <a:bodyPr wrap="square" lIns="0" tIns="0" rIns="0" bIns="0" anchor="t">
             <a:spAutoFit/>
           </a:bodyPr>
           <a:lstStyle/>
@@ -9773,6 +9870,7 @@
           <a:lstStyle/>
           <a:p>
             <a:pPr algn="ctr"/>
+            <a:endParaRPr/>
           </a:p>
         </p:txBody>
       </p:sp>
@@ -9816,6 +9914,7 @@
           <a:lstStyle/>
           <a:p>
             <a:pPr algn="ctr"/>
+            <a:endParaRPr/>
           </a:p>
         </p:txBody>
       </p:sp>
@@ -9836,7 +9935,7 @@
           <a:noFill/>
         </p:spPr>
         <p:txBody>
-          <a:bodyPr wrap="square" anchor="t" lIns="0" rIns="0" tIns="0" bIns="0">
+          <a:bodyPr wrap="square" lIns="0" tIns="0" rIns="0" bIns="0" anchor="t">
             <a:spAutoFit/>
           </a:bodyPr>
           <a:lstStyle/>
@@ -9871,7 +9970,7 @@
           <a:noFill/>
         </p:spPr>
         <p:txBody>
-          <a:bodyPr wrap="square" anchor="t" lIns="0" rIns="0" tIns="0" bIns="0">
+          <a:bodyPr wrap="square" lIns="0" tIns="0" rIns="0" bIns="0" anchor="t">
             <a:spAutoFit/>
           </a:bodyPr>
           <a:lstStyle/>
@@ -9906,7 +10005,7 @@
           <a:noFill/>
         </p:spPr>
         <p:txBody>
-          <a:bodyPr wrap="square" anchor="t" lIns="0" rIns="0" tIns="0" bIns="0">
+          <a:bodyPr wrap="square" lIns="0" tIns="0" rIns="0" bIns="0" anchor="t">
             <a:spAutoFit/>
           </a:bodyPr>
           <a:lstStyle/>
@@ -9942,7 +10041,7 @@
           <a:noFill/>
         </p:spPr>
         <p:txBody>
-          <a:bodyPr wrap="square" anchor="t" lIns="0" rIns="0" tIns="0" bIns="0">
+          <a:bodyPr wrap="square" lIns="0" tIns="0" rIns="0" bIns="0" anchor="t">
             <a:spAutoFit/>
           </a:bodyPr>
           <a:lstStyle/>
@@ -9977,7 +10076,7 @@
           <a:noFill/>
         </p:spPr>
         <p:txBody>
-          <a:bodyPr wrap="square" anchor="t" lIns="0" rIns="0" tIns="0" bIns="0">
+          <a:bodyPr wrap="square" lIns="0" tIns="0" rIns="0" bIns="0" anchor="t">
             <a:spAutoFit/>
           </a:bodyPr>
           <a:lstStyle/>
@@ -10012,7 +10111,7 @@
           <a:noFill/>
         </p:spPr>
         <p:txBody>
-          <a:bodyPr wrap="square" anchor="t" lIns="0" rIns="0" tIns="0" bIns="0">
+          <a:bodyPr wrap="square" lIns="0" tIns="0" rIns="0" bIns="0" anchor="t">
             <a:spAutoFit/>
           </a:bodyPr>
           <a:lstStyle/>
@@ -10039,7 +10138,7 @@
 </file>
 
 <file path=ppt/slides/slide5.xml><?xml version="1.0" encoding="utf-8"?>
-<p:sld xmlns:a="http://schemas.openxmlformats.org/drawingml/2006/main" xmlns:p="http://schemas.openxmlformats.org/presentationml/2006/main" xmlns:r="http://schemas.openxmlformats.org/officeDocument/2006/relationships">
+<p:sld xmlns:a="http://schemas.openxmlformats.org/drawingml/2006/main" xmlns:r="http://schemas.openxmlformats.org/officeDocument/2006/relationships" xmlns:p="http://schemas.openxmlformats.org/presentationml/2006/main">
   <p:cSld>
     <p:spTree>
       <p:nvGrpSpPr>
@@ -10047,7 +10146,14 @@
         <p:cNvGrpSpPr/>
         <p:nvPr/>
       </p:nvGrpSpPr>
-      <p:grpSpPr/>
+      <p:grpSpPr>
+        <a:xfrm>
+          <a:off x="0" y="0"/>
+          <a:ext cx="0" cy="0"/>
+          <a:chOff x="0" y="0"/>
+          <a:chExt cx="0" cy="0"/>
+        </a:xfrm>
+      </p:grpSpPr>
       <p:sp>
         <p:nvSpPr>
           <p:cNvPr id="2" name="Rectangle 1"/>
@@ -10088,6 +10194,7 @@
           <a:lstStyle/>
           <a:p>
             <a:pPr algn="ctr"/>
+            <a:endParaRPr/>
           </a:p>
         </p:txBody>
       </p:sp>
@@ -10131,6 +10238,7 @@
           <a:lstStyle/>
           <a:p>
             <a:pPr algn="ctr"/>
+            <a:endParaRPr/>
           </a:p>
         </p:txBody>
       </p:sp>
@@ -10170,7 +10278,7 @@
           </a:fontRef>
         </p:style>
         <p:txBody>
-          <a:bodyPr rtlCol="0" anchor="ctr" lIns="0" rIns="0" tIns="0" bIns="0"/>
+          <a:bodyPr lIns="0" tIns="0" rIns="0" bIns="0" rtlCol="0" anchor="ctr"/>
           <a:lstStyle/>
           <a:p>
             <a:pPr algn="ctr"/>
@@ -10203,7 +10311,7 @@
           <a:noFill/>
         </p:spPr>
         <p:txBody>
-          <a:bodyPr wrap="square" anchor="t" lIns="0" rIns="0" tIns="0" bIns="0">
+          <a:bodyPr wrap="square" lIns="0" tIns="0" rIns="0" bIns="0" anchor="t">
             <a:spAutoFit/>
           </a:bodyPr>
           <a:lstStyle/>
@@ -10238,7 +10346,7 @@
           <a:noFill/>
         </p:spPr>
         <p:txBody>
-          <a:bodyPr wrap="square" anchor="t" lIns="0" rIns="0" tIns="0" bIns="0">
+          <a:bodyPr wrap="square" lIns="0" tIns="0" rIns="0" bIns="0" anchor="t">
             <a:spAutoFit/>
           </a:bodyPr>
           <a:lstStyle/>
@@ -10273,7 +10381,7 @@
           <a:noFill/>
         </p:spPr>
         <p:txBody>
-          <a:bodyPr wrap="square" anchor="t" lIns="0" rIns="0" tIns="0" bIns="0">
+          <a:bodyPr wrap="square" lIns="0" tIns="0" rIns="0" bIns="0" anchor="t">
             <a:spAutoFit/>
           </a:bodyPr>
           <a:lstStyle/>
@@ -10308,7 +10416,7 @@
           <a:noFill/>
         </p:spPr>
         <p:txBody>
-          <a:bodyPr wrap="square" anchor="t" lIns="0" rIns="0" tIns="0" bIns="0">
+          <a:bodyPr wrap="square" lIns="0" tIns="0" rIns="0" bIns="0" anchor="t">
             <a:spAutoFit/>
           </a:bodyPr>
           <a:lstStyle/>
@@ -10366,6 +10474,7 @@
           <a:lstStyle/>
           <a:p>
             <a:pPr algn="ctr"/>
+            <a:endParaRPr/>
           </a:p>
         </p:txBody>
       </p:sp>
@@ -10386,7 +10495,7 @@
           <a:noFill/>
         </p:spPr>
         <p:txBody>
-          <a:bodyPr wrap="square" anchor="t" lIns="0" rIns="0" tIns="0" bIns="0">
+          <a:bodyPr wrap="square" lIns="0" tIns="0" rIns="0" bIns="0" anchor="t">
             <a:spAutoFit/>
           </a:bodyPr>
           <a:lstStyle/>
@@ -10444,6 +10553,7 @@
           <a:lstStyle/>
           <a:p>
             <a:pPr algn="ctr"/>
+            <a:endParaRPr/>
           </a:p>
         </p:txBody>
       </p:sp>
@@ -10464,7 +10574,7 @@
           <a:noFill/>
         </p:spPr>
         <p:txBody>
-          <a:bodyPr wrap="square" anchor="t" lIns="0" rIns="0" tIns="0" bIns="0">
+          <a:bodyPr wrap="square" lIns="0" tIns="0" rIns="0" bIns="0" anchor="t">
             <a:spAutoFit/>
           </a:bodyPr>
           <a:lstStyle/>
@@ -10522,6 +10632,7 @@
           <a:lstStyle/>
           <a:p>
             <a:pPr algn="ctr"/>
+            <a:endParaRPr/>
           </a:p>
         </p:txBody>
       </p:sp>
@@ -10542,7 +10653,7 @@
           <a:noFill/>
         </p:spPr>
         <p:txBody>
-          <a:bodyPr wrap="square" anchor="t" lIns="0" rIns="0" tIns="0" bIns="0">
+          <a:bodyPr wrap="square" lIns="0" tIns="0" rIns="0" bIns="0" anchor="t">
             <a:spAutoFit/>
           </a:bodyPr>
           <a:lstStyle/>
@@ -10600,6 +10711,7 @@
           <a:lstStyle/>
           <a:p>
             <a:pPr algn="ctr"/>
+            <a:endParaRPr/>
           </a:p>
         </p:txBody>
       </p:sp>
@@ -10620,7 +10732,7 @@
           <a:noFill/>
         </p:spPr>
         <p:txBody>
-          <a:bodyPr wrap="square" anchor="t" lIns="0" rIns="0" tIns="0" bIns="0">
+          <a:bodyPr wrap="square" lIns="0" tIns="0" rIns="0" bIns="0" anchor="t">
             <a:spAutoFit/>
           </a:bodyPr>
           <a:lstStyle/>
@@ -10680,6 +10792,7 @@
           <a:lstStyle/>
           <a:p>
             <a:pPr algn="ctr"/>
+            <a:endParaRPr/>
           </a:p>
         </p:txBody>
       </p:sp>
@@ -10700,7 +10813,7 @@
           <a:noFill/>
         </p:spPr>
         <p:txBody>
-          <a:bodyPr wrap="square" anchor="t" lIns="0" rIns="0" tIns="0" bIns="0">
+          <a:bodyPr wrap="square" lIns="0" tIns="0" rIns="0" bIns="0" anchor="t">
             <a:spAutoFit/>
           </a:bodyPr>
           <a:lstStyle/>
@@ -10760,6 +10873,7 @@
           <a:lstStyle/>
           <a:p>
             <a:pPr algn="ctr"/>
+            <a:endParaRPr/>
           </a:p>
         </p:txBody>
       </p:sp>
@@ -10780,7 +10894,7 @@
           <a:noFill/>
         </p:spPr>
         <p:txBody>
-          <a:bodyPr wrap="square" anchor="t" lIns="0" rIns="0" tIns="0" bIns="0">
+          <a:bodyPr wrap="square" lIns="0" tIns="0" rIns="0" bIns="0" anchor="t">
             <a:spAutoFit/>
           </a:bodyPr>
           <a:lstStyle/>
@@ -10840,6 +10954,7 @@
           <a:lstStyle/>
           <a:p>
             <a:pPr algn="ctr"/>
+            <a:endParaRPr/>
           </a:p>
         </p:txBody>
       </p:sp>
@@ -10860,7 +10975,7 @@
           <a:noFill/>
         </p:spPr>
         <p:txBody>
-          <a:bodyPr wrap="square" anchor="t" lIns="0" rIns="0" tIns="0" bIns="0">
+          <a:bodyPr wrap="square" lIns="0" tIns="0" rIns="0" bIns="0" anchor="t">
             <a:spAutoFit/>
           </a:bodyPr>
           <a:lstStyle/>
@@ -10918,6 +11033,7 @@
           <a:lstStyle/>
           <a:p>
             <a:pPr algn="ctr"/>
+            <a:endParaRPr/>
           </a:p>
         </p:txBody>
       </p:sp>
@@ -10938,7 +11054,7 @@
           <a:noFill/>
         </p:spPr>
         <p:txBody>
-          <a:bodyPr wrap="square" anchor="t" lIns="0" rIns="0" tIns="0" bIns="0">
+          <a:bodyPr wrap="square" lIns="0" tIns="0" rIns="0" bIns="0" anchor="t">
             <a:spAutoFit/>
           </a:bodyPr>
           <a:lstStyle/>
@@ -10998,6 +11114,7 @@
           <a:lstStyle/>
           <a:p>
             <a:pPr algn="ctr"/>
+            <a:endParaRPr/>
           </a:p>
         </p:txBody>
       </p:sp>
@@ -11018,7 +11135,7 @@
           <a:noFill/>
         </p:spPr>
         <p:txBody>
-          <a:bodyPr wrap="square" anchor="t" lIns="0" rIns="0" tIns="0" bIns="0">
+          <a:bodyPr wrap="square" lIns="0" tIns="0" rIns="0" bIns="0" anchor="t">
             <a:spAutoFit/>
           </a:bodyPr>
           <a:lstStyle/>
@@ -11078,6 +11195,7 @@
           <a:lstStyle/>
           <a:p>
             <a:pPr algn="ctr"/>
+            <a:endParaRPr/>
           </a:p>
         </p:txBody>
       </p:sp>
@@ -11098,7 +11216,7 @@
           <a:noFill/>
         </p:spPr>
         <p:txBody>
-          <a:bodyPr wrap="square" anchor="t" lIns="0" rIns="0" tIns="0" bIns="0">
+          <a:bodyPr wrap="square" lIns="0" tIns="0" rIns="0" bIns="0" anchor="t">
             <a:spAutoFit/>
           </a:bodyPr>
           <a:lstStyle/>
@@ -11158,6 +11276,7 @@
           <a:lstStyle/>
           <a:p>
             <a:pPr algn="ctr"/>
+            <a:endParaRPr/>
           </a:p>
         </p:txBody>
       </p:sp>
@@ -11178,7 +11297,7 @@
           <a:noFill/>
         </p:spPr>
         <p:txBody>
-          <a:bodyPr wrap="square" anchor="t" lIns="0" rIns="0" tIns="0" bIns="0">
+          <a:bodyPr wrap="square" lIns="0" tIns="0" rIns="0" bIns="0" anchor="t">
             <a:spAutoFit/>
           </a:bodyPr>
           <a:lstStyle/>
@@ -11236,6 +11355,7 @@
           <a:lstStyle/>
           <a:p>
             <a:pPr algn="ctr"/>
+            <a:endParaRPr/>
           </a:p>
         </p:txBody>
       </p:sp>
@@ -11256,7 +11376,7 @@
           <a:noFill/>
         </p:spPr>
         <p:txBody>
-          <a:bodyPr wrap="square" anchor="t" lIns="0" rIns="0" tIns="0" bIns="0">
+          <a:bodyPr wrap="square" lIns="0" tIns="0" rIns="0" bIns="0" anchor="t">
             <a:spAutoFit/>
           </a:bodyPr>
           <a:lstStyle/>
@@ -11316,6 +11436,7 @@
           <a:lstStyle/>
           <a:p>
             <a:pPr algn="ctr"/>
+            <a:endParaRPr/>
           </a:p>
         </p:txBody>
       </p:sp>
@@ -11336,7 +11457,7 @@
           <a:noFill/>
         </p:spPr>
         <p:txBody>
-          <a:bodyPr wrap="square" anchor="t" lIns="0" rIns="0" tIns="0" bIns="0">
+          <a:bodyPr wrap="square" lIns="0" tIns="0" rIns="0" bIns="0" anchor="t">
             <a:spAutoFit/>
           </a:bodyPr>
           <a:lstStyle/>
@@ -11396,6 +11517,7 @@
           <a:lstStyle/>
           <a:p>
             <a:pPr algn="ctr"/>
+            <a:endParaRPr/>
           </a:p>
         </p:txBody>
       </p:sp>
@@ -11416,7 +11538,7 @@
           <a:noFill/>
         </p:spPr>
         <p:txBody>
-          <a:bodyPr wrap="square" anchor="t" lIns="0" rIns="0" tIns="0" bIns="0">
+          <a:bodyPr wrap="square" lIns="0" tIns="0" rIns="0" bIns="0" anchor="t">
             <a:spAutoFit/>
           </a:bodyPr>
           <a:lstStyle/>
@@ -11476,6 +11598,7 @@
           <a:lstStyle/>
           <a:p>
             <a:pPr algn="ctr"/>
+            <a:endParaRPr/>
           </a:p>
         </p:txBody>
       </p:sp>
@@ -11496,7 +11619,7 @@
           <a:noFill/>
         </p:spPr>
         <p:txBody>
-          <a:bodyPr wrap="square" anchor="t" lIns="0" rIns="0" tIns="0" bIns="0">
+          <a:bodyPr wrap="square" lIns="0" tIns="0" rIns="0" bIns="0" anchor="t">
             <a:spAutoFit/>
           </a:bodyPr>
           <a:lstStyle/>
@@ -11554,6 +11677,7 @@
           <a:lstStyle/>
           <a:p>
             <a:pPr algn="ctr"/>
+            <a:endParaRPr/>
           </a:p>
         </p:txBody>
       </p:sp>
@@ -11574,7 +11698,7 @@
           <a:noFill/>
         </p:spPr>
         <p:txBody>
-          <a:bodyPr wrap="square" anchor="t" lIns="0" rIns="0" tIns="0" bIns="0">
+          <a:bodyPr wrap="square" lIns="0" tIns="0" rIns="0" bIns="0" anchor="t">
             <a:spAutoFit/>
           </a:bodyPr>
           <a:lstStyle/>
@@ -11634,6 +11758,7 @@
           <a:lstStyle/>
           <a:p>
             <a:pPr algn="ctr"/>
+            <a:endParaRPr/>
           </a:p>
         </p:txBody>
       </p:sp>
@@ -11654,7 +11779,7 @@
           <a:noFill/>
         </p:spPr>
         <p:txBody>
-          <a:bodyPr wrap="square" anchor="t" lIns="0" rIns="0" tIns="0" bIns="0">
+          <a:bodyPr wrap="square" lIns="0" tIns="0" rIns="0" bIns="0" anchor="t">
             <a:spAutoFit/>
           </a:bodyPr>
           <a:lstStyle/>
@@ -11714,6 +11839,7 @@
           <a:lstStyle/>
           <a:p>
             <a:pPr algn="ctr"/>
+            <a:endParaRPr/>
           </a:p>
         </p:txBody>
       </p:sp>
@@ -11734,7 +11860,7 @@
           <a:noFill/>
         </p:spPr>
         <p:txBody>
-          <a:bodyPr wrap="square" anchor="t" lIns="0" rIns="0" tIns="0" bIns="0">
+          <a:bodyPr wrap="square" lIns="0" tIns="0" rIns="0" bIns="0" anchor="t">
             <a:spAutoFit/>
           </a:bodyPr>
           <a:lstStyle/>
@@ -11794,6 +11920,7 @@
           <a:lstStyle/>
           <a:p>
             <a:pPr algn="ctr"/>
+            <a:endParaRPr/>
           </a:p>
         </p:txBody>
       </p:sp>
@@ -11814,7 +11941,7 @@
           <a:noFill/>
         </p:spPr>
         <p:txBody>
-          <a:bodyPr wrap="square" anchor="t" lIns="0" rIns="0" tIns="0" bIns="0">
+          <a:bodyPr wrap="square" lIns="0" tIns="0" rIns="0" bIns="0" anchor="t">
             <a:spAutoFit/>
           </a:bodyPr>
           <a:lstStyle/>
@@ -11872,6 +11999,7 @@
           <a:lstStyle/>
           <a:p>
             <a:pPr algn="ctr"/>
+            <a:endParaRPr/>
           </a:p>
         </p:txBody>
       </p:sp>
@@ -11892,7 +12020,7 @@
           <a:noFill/>
         </p:spPr>
         <p:txBody>
-          <a:bodyPr wrap="square" anchor="t" lIns="0" rIns="0" tIns="0" bIns="0">
+          <a:bodyPr wrap="square" lIns="0" tIns="0" rIns="0" bIns="0" anchor="t">
             <a:spAutoFit/>
           </a:bodyPr>
           <a:lstStyle/>
@@ -11952,6 +12080,7 @@
           <a:lstStyle/>
           <a:p>
             <a:pPr algn="ctr"/>
+            <a:endParaRPr/>
           </a:p>
         </p:txBody>
       </p:sp>
@@ -11972,7 +12101,7 @@
           <a:noFill/>
         </p:spPr>
         <p:txBody>
-          <a:bodyPr wrap="square" anchor="t" lIns="0" rIns="0" tIns="0" bIns="0">
+          <a:bodyPr wrap="square" lIns="0" tIns="0" rIns="0" bIns="0" anchor="t">
             <a:spAutoFit/>
           </a:bodyPr>
           <a:lstStyle/>
@@ -12032,6 +12161,7 @@
           <a:lstStyle/>
           <a:p>
             <a:pPr algn="ctr"/>
+            <a:endParaRPr/>
           </a:p>
         </p:txBody>
       </p:sp>
@@ -12052,7 +12182,7 @@
           <a:noFill/>
         </p:spPr>
         <p:txBody>
-          <a:bodyPr wrap="square" anchor="t" lIns="0" rIns="0" tIns="0" bIns="0">
+          <a:bodyPr wrap="square" lIns="0" tIns="0" rIns="0" bIns="0" anchor="t">
             <a:spAutoFit/>
           </a:bodyPr>
           <a:lstStyle/>
@@ -12112,6 +12242,7 @@
           <a:lstStyle/>
           <a:p>
             <a:pPr algn="ctr"/>
+            <a:endParaRPr/>
           </a:p>
         </p:txBody>
       </p:sp>
@@ -12132,7 +12263,7 @@
           <a:noFill/>
         </p:spPr>
         <p:txBody>
-          <a:bodyPr wrap="square" anchor="t" lIns="0" rIns="0" tIns="0" bIns="0">
+          <a:bodyPr wrap="square" lIns="0" tIns="0" rIns="0" bIns="0" anchor="t">
             <a:spAutoFit/>
           </a:bodyPr>
           <a:lstStyle/>
@@ -12190,6 +12321,7 @@
           <a:lstStyle/>
           <a:p>
             <a:pPr algn="ctr"/>
+            <a:endParaRPr/>
           </a:p>
         </p:txBody>
       </p:sp>
@@ -12210,7 +12342,7 @@
           <a:noFill/>
         </p:spPr>
         <p:txBody>
-          <a:bodyPr wrap="square" anchor="t" lIns="0" rIns="0" tIns="0" bIns="0">
+          <a:bodyPr wrap="square" lIns="0" tIns="0" rIns="0" bIns="0" anchor="t">
             <a:spAutoFit/>
           </a:bodyPr>
           <a:lstStyle/>
@@ -12270,6 +12402,7 @@
           <a:lstStyle/>
           <a:p>
             <a:pPr algn="ctr"/>
+            <a:endParaRPr/>
           </a:p>
         </p:txBody>
       </p:sp>
@@ -12290,7 +12423,7 @@
           <a:noFill/>
         </p:spPr>
         <p:txBody>
-          <a:bodyPr wrap="square" anchor="t" lIns="0" rIns="0" tIns="0" bIns="0">
+          <a:bodyPr wrap="square" lIns="0" tIns="0" rIns="0" bIns="0" anchor="t">
             <a:spAutoFit/>
           </a:bodyPr>
           <a:lstStyle/>
@@ -12350,6 +12483,7 @@
           <a:lstStyle/>
           <a:p>
             <a:pPr algn="ctr"/>
+            <a:endParaRPr/>
           </a:p>
         </p:txBody>
       </p:sp>
@@ -12370,7 +12504,7 @@
           <a:noFill/>
         </p:spPr>
         <p:txBody>
-          <a:bodyPr wrap="square" anchor="t" lIns="0" rIns="0" tIns="0" bIns="0">
+          <a:bodyPr wrap="square" lIns="0" tIns="0" rIns="0" bIns="0" anchor="t">
             <a:spAutoFit/>
           </a:bodyPr>
           <a:lstStyle/>
@@ -12430,6 +12564,7 @@
           <a:lstStyle/>
           <a:p>
             <a:pPr algn="ctr"/>
+            <a:endParaRPr/>
           </a:p>
         </p:txBody>
       </p:sp>
@@ -12450,7 +12585,7 @@
           <a:noFill/>
         </p:spPr>
         <p:txBody>
-          <a:bodyPr wrap="square" anchor="t" lIns="0" rIns="0" tIns="0" bIns="0">
+          <a:bodyPr wrap="square" lIns="0" tIns="0" rIns="0" bIns="0" anchor="t">
             <a:spAutoFit/>
           </a:bodyPr>
           <a:lstStyle/>
@@ -12508,6 +12643,7 @@
           <a:lstStyle/>
           <a:p>
             <a:pPr algn="ctr"/>
+            <a:endParaRPr/>
           </a:p>
         </p:txBody>
       </p:sp>
@@ -12528,7 +12664,7 @@
           <a:noFill/>
         </p:spPr>
         <p:txBody>
-          <a:bodyPr wrap="square" anchor="t" lIns="0" rIns="0" tIns="0" bIns="0">
+          <a:bodyPr wrap="square" lIns="0" tIns="0" rIns="0" bIns="0" anchor="t">
             <a:spAutoFit/>
           </a:bodyPr>
           <a:lstStyle/>
@@ -12588,6 +12724,7 @@
           <a:lstStyle/>
           <a:p>
             <a:pPr algn="ctr"/>
+            <a:endParaRPr/>
           </a:p>
         </p:txBody>
       </p:sp>
@@ -12608,7 +12745,7 @@
           <a:noFill/>
         </p:spPr>
         <p:txBody>
-          <a:bodyPr wrap="square" anchor="t" lIns="0" rIns="0" tIns="0" bIns="0">
+          <a:bodyPr wrap="square" lIns="0" tIns="0" rIns="0" bIns="0" anchor="t">
             <a:spAutoFit/>
           </a:bodyPr>
           <a:lstStyle/>
@@ -12668,6 +12805,7 @@
           <a:lstStyle/>
           <a:p>
             <a:pPr algn="ctr"/>
+            <a:endParaRPr/>
           </a:p>
         </p:txBody>
       </p:sp>
@@ -12688,7 +12826,7 @@
           <a:noFill/>
         </p:spPr>
         <p:txBody>
-          <a:bodyPr wrap="square" anchor="t" lIns="0" rIns="0" tIns="0" bIns="0">
+          <a:bodyPr wrap="square" lIns="0" tIns="0" rIns="0" bIns="0" anchor="t">
             <a:spAutoFit/>
           </a:bodyPr>
           <a:lstStyle/>
@@ -12748,6 +12886,7 @@
           <a:lstStyle/>
           <a:p>
             <a:pPr algn="ctr"/>
+            <a:endParaRPr/>
           </a:p>
         </p:txBody>
       </p:sp>
@@ -12768,7 +12907,7 @@
           <a:noFill/>
         </p:spPr>
         <p:txBody>
-          <a:bodyPr wrap="square" anchor="t" lIns="0" rIns="0" tIns="0" bIns="0">
+          <a:bodyPr wrap="square" lIns="0" tIns="0" rIns="0" bIns="0" anchor="t">
             <a:spAutoFit/>
           </a:bodyPr>
           <a:lstStyle/>
@@ -12826,6 +12965,7 @@
           <a:lstStyle/>
           <a:p>
             <a:pPr algn="ctr"/>
+            <a:endParaRPr/>
           </a:p>
         </p:txBody>
       </p:sp>
@@ -12846,7 +12986,7 @@
           <a:noFill/>
         </p:spPr>
         <p:txBody>
-          <a:bodyPr wrap="square" anchor="t" lIns="0" rIns="0" tIns="0" bIns="0">
+          <a:bodyPr wrap="square" lIns="0" tIns="0" rIns="0" bIns="0" anchor="t">
             <a:spAutoFit/>
           </a:bodyPr>
           <a:lstStyle/>
@@ -12881,7 +13021,7 @@
           <a:noFill/>
         </p:spPr>
         <p:txBody>
-          <a:bodyPr wrap="square" anchor="t" lIns="0" rIns="0" tIns="0" bIns="0">
+          <a:bodyPr wrap="square" lIns="0" tIns="0" rIns="0" bIns="0" anchor="t">
             <a:spAutoFit/>
           </a:bodyPr>
           <a:lstStyle/>
@@ -12916,7 +13056,7 @@
           <a:noFill/>
         </p:spPr>
         <p:txBody>
-          <a:bodyPr wrap="square" anchor="t" lIns="0" rIns="0" tIns="0" bIns="0">
+          <a:bodyPr wrap="square" lIns="0" tIns="0" rIns="0" bIns="0" anchor="t">
             <a:spAutoFit/>
           </a:bodyPr>
           <a:lstStyle/>
@@ -12943,7 +13083,7 @@
 </file>
 
 <file path=ppt/slides/slide6.xml><?xml version="1.0" encoding="utf-8"?>
-<p:sld xmlns:a="http://schemas.openxmlformats.org/drawingml/2006/main" xmlns:p="http://schemas.openxmlformats.org/presentationml/2006/main" xmlns:r="http://schemas.openxmlformats.org/officeDocument/2006/relationships">
+<p:sld xmlns:a="http://schemas.openxmlformats.org/drawingml/2006/main" xmlns:r="http://schemas.openxmlformats.org/officeDocument/2006/relationships" xmlns:p="http://schemas.openxmlformats.org/presentationml/2006/main">
   <p:cSld>
     <p:spTree>
       <p:nvGrpSpPr>
@@ -12951,7 +13091,14 @@
         <p:cNvGrpSpPr/>
         <p:nvPr/>
       </p:nvGrpSpPr>
-      <p:grpSpPr/>
+      <p:grpSpPr>
+        <a:xfrm>
+          <a:off x="0" y="0"/>
+          <a:ext cx="0" cy="0"/>
+          <a:chOff x="0" y="0"/>
+          <a:chExt cx="0" cy="0"/>
+        </a:xfrm>
+      </p:grpSpPr>
       <p:sp>
         <p:nvSpPr>
           <p:cNvPr id="2" name="Rectangle 1"/>
@@ -12992,6 +13139,7 @@
           <a:lstStyle/>
           <a:p>
             <a:pPr algn="ctr"/>
+            <a:endParaRPr/>
           </a:p>
         </p:txBody>
       </p:sp>
@@ -13035,6 +13183,7 @@
           <a:lstStyle/>
           <a:p>
             <a:pPr algn="ctr"/>
+            <a:endParaRPr/>
           </a:p>
         </p:txBody>
       </p:sp>
@@ -13074,7 +13223,7 @@
           </a:fontRef>
         </p:style>
         <p:txBody>
-          <a:bodyPr rtlCol="0" anchor="ctr" lIns="0" rIns="0" tIns="0" bIns="0"/>
+          <a:bodyPr lIns="0" tIns="0" rIns="0" bIns="0" rtlCol="0" anchor="ctr"/>
           <a:lstStyle/>
           <a:p>
             <a:pPr algn="ctr"/>
@@ -13107,7 +13256,7 @@
           <a:noFill/>
         </p:spPr>
         <p:txBody>
-          <a:bodyPr wrap="square" anchor="t" lIns="0" rIns="0" tIns="0" bIns="0">
+          <a:bodyPr wrap="square" lIns="0" tIns="0" rIns="0" bIns="0" anchor="t">
             <a:spAutoFit/>
           </a:bodyPr>
           <a:lstStyle/>
@@ -13142,7 +13291,7 @@
           <a:noFill/>
         </p:spPr>
         <p:txBody>
-          <a:bodyPr wrap="square" anchor="t" lIns="0" rIns="0" tIns="0" bIns="0">
+          <a:bodyPr wrap="square" lIns="0" tIns="0" rIns="0" bIns="0" anchor="t">
             <a:spAutoFit/>
           </a:bodyPr>
           <a:lstStyle/>
@@ -13177,7 +13326,7 @@
           <a:noFill/>
         </p:spPr>
         <p:txBody>
-          <a:bodyPr wrap="square" anchor="t" lIns="0" rIns="0" tIns="0" bIns="0">
+          <a:bodyPr wrap="square" lIns="0" tIns="0" rIns="0" bIns="0" anchor="t">
             <a:spAutoFit/>
           </a:bodyPr>
           <a:lstStyle/>
@@ -13212,7 +13361,7 @@
           <a:noFill/>
         </p:spPr>
         <p:txBody>
-          <a:bodyPr wrap="square" anchor="t" lIns="0" rIns="0" tIns="0" bIns="0">
+          <a:bodyPr wrap="square" lIns="0" tIns="0" rIns="0" bIns="0" anchor="t">
             <a:spAutoFit/>
           </a:bodyPr>
           <a:lstStyle/>
@@ -13272,6 +13421,7 @@
           <a:lstStyle/>
           <a:p>
             <a:pPr algn="ctr"/>
+            <a:endParaRPr/>
           </a:p>
         </p:txBody>
       </p:sp>
@@ -13292,7 +13442,7 @@
           <a:noFill/>
         </p:spPr>
         <p:txBody>
-          <a:bodyPr wrap="square" anchor="t" lIns="0" rIns="0" tIns="0" bIns="0">
+          <a:bodyPr wrap="square" lIns="0" tIns="0" rIns="0" bIns="0" anchor="t">
             <a:spAutoFit/>
           </a:bodyPr>
           <a:lstStyle/>
@@ -13327,7 +13477,7 @@
           <a:noFill/>
         </p:spPr>
         <p:txBody>
-          <a:bodyPr wrap="square" anchor="t" lIns="0" rIns="0" tIns="0" bIns="0">
+          <a:bodyPr wrap="square" lIns="0" tIns="0" rIns="0" bIns="0" anchor="t">
             <a:spAutoFit/>
           </a:bodyPr>
           <a:lstStyle/>
@@ -13362,7 +13512,7 @@
           <a:noFill/>
         </p:spPr>
         <p:txBody>
-          <a:bodyPr wrap="square" anchor="t" lIns="0" rIns="0" tIns="0" bIns="0">
+          <a:bodyPr wrap="square" lIns="0" tIns="0" rIns="0" bIns="0" anchor="t">
             <a:spAutoFit/>
           </a:bodyPr>
           <a:lstStyle/>
@@ -13421,6 +13571,7 @@
           <a:lstStyle/>
           <a:p>
             <a:pPr algn="ctr"/>
+            <a:endParaRPr/>
           </a:p>
         </p:txBody>
       </p:sp>
@@ -13441,7 +13592,7 @@
           <a:noFill/>
         </p:spPr>
         <p:txBody>
-          <a:bodyPr wrap="square" anchor="t" lIns="0" rIns="0" tIns="0" bIns="0">
+          <a:bodyPr wrap="square" lIns="0" tIns="0" rIns="0" bIns="0" anchor="t">
             <a:spAutoFit/>
           </a:bodyPr>
           <a:lstStyle/>
@@ -13501,6 +13652,7 @@
           <a:lstStyle/>
           <a:p>
             <a:pPr algn="ctr"/>
+            <a:endParaRPr/>
           </a:p>
         </p:txBody>
       </p:sp>
@@ -13521,7 +13673,7 @@
           <a:noFill/>
         </p:spPr>
         <p:txBody>
-          <a:bodyPr wrap="square" anchor="t" lIns="0" rIns="0" tIns="0" bIns="0">
+          <a:bodyPr wrap="square" lIns="0" tIns="0" rIns="0" bIns="0" anchor="t">
             <a:spAutoFit/>
           </a:bodyPr>
           <a:lstStyle/>
@@ -13556,7 +13708,7 @@
           <a:noFill/>
         </p:spPr>
         <p:txBody>
-          <a:bodyPr wrap="square" anchor="t" lIns="0" rIns="0" tIns="0" bIns="0">
+          <a:bodyPr wrap="square" lIns="0" tIns="0" rIns="0" bIns="0" anchor="t">
             <a:spAutoFit/>
           </a:bodyPr>
           <a:lstStyle/>
@@ -13591,7 +13743,7 @@
           <a:noFill/>
         </p:spPr>
         <p:txBody>
-          <a:bodyPr wrap="square" anchor="t" lIns="0" rIns="0" tIns="0" bIns="0">
+          <a:bodyPr wrap="square" lIns="0" tIns="0" rIns="0" bIns="0" anchor="t">
             <a:spAutoFit/>
           </a:bodyPr>
           <a:lstStyle/>
@@ -13650,6 +13802,7 @@
           <a:lstStyle/>
           <a:p>
             <a:pPr algn="ctr"/>
+            <a:endParaRPr/>
           </a:p>
         </p:txBody>
       </p:sp>
@@ -13670,7 +13823,7 @@
           <a:noFill/>
         </p:spPr>
         <p:txBody>
-          <a:bodyPr wrap="square" anchor="t" lIns="0" rIns="0" tIns="0" bIns="0">
+          <a:bodyPr wrap="square" lIns="0" tIns="0" rIns="0" bIns="0" anchor="t">
             <a:spAutoFit/>
           </a:bodyPr>
           <a:lstStyle/>
@@ -13730,6 +13883,7 @@
           <a:lstStyle/>
           <a:p>
             <a:pPr algn="ctr"/>
+            <a:endParaRPr/>
           </a:p>
         </p:txBody>
       </p:sp>
@@ -13750,7 +13904,7 @@
           <a:noFill/>
         </p:spPr>
         <p:txBody>
-          <a:bodyPr wrap="square" anchor="t" lIns="0" rIns="0" tIns="0" bIns="0">
+          <a:bodyPr wrap="square" lIns="0" tIns="0" rIns="0" bIns="0" anchor="t">
             <a:spAutoFit/>
           </a:bodyPr>
           <a:lstStyle/>
@@ -13785,7 +13939,7 @@
           <a:noFill/>
         </p:spPr>
         <p:txBody>
-          <a:bodyPr wrap="square" anchor="t" lIns="0" rIns="0" tIns="0" bIns="0">
+          <a:bodyPr wrap="square" lIns="0" tIns="0" rIns="0" bIns="0" anchor="t">
             <a:spAutoFit/>
           </a:bodyPr>
           <a:lstStyle/>
@@ -13820,7 +13974,7 @@
           <a:noFill/>
         </p:spPr>
         <p:txBody>
-          <a:bodyPr wrap="square" anchor="t" lIns="0" rIns="0" tIns="0" bIns="0">
+          <a:bodyPr wrap="square" lIns="0" tIns="0" rIns="0" bIns="0" anchor="t">
             <a:spAutoFit/>
           </a:bodyPr>
           <a:lstStyle/>
@@ -13879,6 +14033,7 @@
           <a:lstStyle/>
           <a:p>
             <a:pPr algn="ctr"/>
+            <a:endParaRPr/>
           </a:p>
         </p:txBody>
       </p:sp>
@@ -13899,7 +14054,7 @@
           <a:noFill/>
         </p:spPr>
         <p:txBody>
-          <a:bodyPr wrap="square" anchor="t" lIns="0" rIns="0" tIns="0" bIns="0">
+          <a:bodyPr wrap="square" lIns="0" tIns="0" rIns="0" bIns="0" anchor="t">
             <a:spAutoFit/>
           </a:bodyPr>
           <a:lstStyle/>
@@ -13959,6 +14114,7 @@
           <a:lstStyle/>
           <a:p>
             <a:pPr algn="ctr"/>
+            <a:endParaRPr/>
           </a:p>
         </p:txBody>
       </p:sp>
@@ -13979,7 +14135,7 @@
           <a:noFill/>
         </p:spPr>
         <p:txBody>
-          <a:bodyPr wrap="square" anchor="t" lIns="0" rIns="0" tIns="0" bIns="0">
+          <a:bodyPr wrap="square" lIns="0" tIns="0" rIns="0" bIns="0" anchor="t">
             <a:spAutoFit/>
           </a:bodyPr>
           <a:lstStyle/>
@@ -14014,7 +14170,7 @@
           <a:noFill/>
         </p:spPr>
         <p:txBody>
-          <a:bodyPr wrap="square" anchor="t" lIns="0" rIns="0" tIns="0" bIns="0">
+          <a:bodyPr wrap="square" lIns="0" tIns="0" rIns="0" bIns="0" anchor="t">
             <a:spAutoFit/>
           </a:bodyPr>
           <a:lstStyle/>
@@ -14049,7 +14205,7 @@
           <a:noFill/>
         </p:spPr>
         <p:txBody>
-          <a:bodyPr wrap="square" anchor="t" lIns="0" rIns="0" tIns="0" bIns="0">
+          <a:bodyPr wrap="square" lIns="0" tIns="0" rIns="0" bIns="0" anchor="t">
             <a:spAutoFit/>
           </a:bodyPr>
           <a:lstStyle/>
@@ -14108,6 +14264,7 @@
           <a:lstStyle/>
           <a:p>
             <a:pPr algn="ctr"/>
+            <a:endParaRPr/>
           </a:p>
         </p:txBody>
       </p:sp>
@@ -14128,7 +14285,7 @@
           <a:noFill/>
         </p:spPr>
         <p:txBody>
-          <a:bodyPr wrap="square" anchor="t" lIns="0" rIns="0" tIns="0" bIns="0">
+          <a:bodyPr wrap="square" lIns="0" tIns="0" rIns="0" bIns="0" anchor="t">
             <a:spAutoFit/>
           </a:bodyPr>
           <a:lstStyle/>
@@ -14163,7 +14320,7 @@
           <a:noFill/>
         </p:spPr>
         <p:txBody>
-          <a:bodyPr wrap="square" anchor="t" lIns="0" rIns="0" tIns="0" bIns="0">
+          <a:bodyPr wrap="square" lIns="0" tIns="0" rIns="0" bIns="0" anchor="t">
             <a:spAutoFit/>
           </a:bodyPr>
           <a:lstStyle/>
@@ -14198,7 +14355,7 @@
           <a:noFill/>
         </p:spPr>
         <p:txBody>
-          <a:bodyPr wrap="square" anchor="t" lIns="0" rIns="0" tIns="0" bIns="0">
+          <a:bodyPr wrap="square" lIns="0" tIns="0" rIns="0" bIns="0" anchor="t">
             <a:spAutoFit/>
           </a:bodyPr>
           <a:lstStyle/>
@@ -14225,7 +14382,7 @@
 </file>
 
 <file path=ppt/slides/slide7.xml><?xml version="1.0" encoding="utf-8"?>
-<p:sld xmlns:a="http://schemas.openxmlformats.org/drawingml/2006/main" xmlns:p="http://schemas.openxmlformats.org/presentationml/2006/main" xmlns:r="http://schemas.openxmlformats.org/officeDocument/2006/relationships">
+<p:sld xmlns:a="http://schemas.openxmlformats.org/drawingml/2006/main" xmlns:r="http://schemas.openxmlformats.org/officeDocument/2006/relationships" xmlns:p="http://schemas.openxmlformats.org/presentationml/2006/main">
   <p:cSld>
     <p:spTree>
       <p:nvGrpSpPr>
@@ -14233,7 +14390,14 @@
         <p:cNvGrpSpPr/>
         <p:nvPr/>
       </p:nvGrpSpPr>
-      <p:grpSpPr/>
+      <p:grpSpPr>
+        <a:xfrm>
+          <a:off x="0" y="0"/>
+          <a:ext cx="0" cy="0"/>
+          <a:chOff x="0" y="0"/>
+          <a:chExt cx="0" cy="0"/>
+        </a:xfrm>
+      </p:grpSpPr>
       <p:sp>
         <p:nvSpPr>
           <p:cNvPr id="2" name="Rectangle 1"/>
@@ -14274,6 +14438,7 @@
           <a:lstStyle/>
           <a:p>
             <a:pPr algn="ctr"/>
+            <a:endParaRPr/>
           </a:p>
         </p:txBody>
       </p:sp>
@@ -14317,6 +14482,7 @@
           <a:lstStyle/>
           <a:p>
             <a:pPr algn="ctr"/>
+            <a:endParaRPr/>
           </a:p>
         </p:txBody>
       </p:sp>
@@ -14356,7 +14522,7 @@
           </a:fontRef>
         </p:style>
         <p:txBody>
-          <a:bodyPr rtlCol="0" anchor="ctr" lIns="0" rIns="0" tIns="0" bIns="0"/>
+          <a:bodyPr lIns="0" tIns="0" rIns="0" bIns="0" rtlCol="0" anchor="ctr"/>
           <a:lstStyle/>
           <a:p>
             <a:pPr algn="ctr"/>
@@ -14389,7 +14555,7 @@
           <a:noFill/>
         </p:spPr>
         <p:txBody>
-          <a:bodyPr wrap="square" anchor="t" lIns="0" rIns="0" tIns="0" bIns="0">
+          <a:bodyPr wrap="square" lIns="0" tIns="0" rIns="0" bIns="0" anchor="t">
             <a:spAutoFit/>
           </a:bodyPr>
           <a:lstStyle/>
@@ -14424,7 +14590,7 @@
           <a:noFill/>
         </p:spPr>
         <p:txBody>
-          <a:bodyPr wrap="square" anchor="t" lIns="0" rIns="0" tIns="0" bIns="0">
+          <a:bodyPr wrap="square" lIns="0" tIns="0" rIns="0" bIns="0" anchor="t">
             <a:spAutoFit/>
           </a:bodyPr>
           <a:lstStyle/>
@@ -14459,7 +14625,7 @@
           <a:noFill/>
         </p:spPr>
         <p:txBody>
-          <a:bodyPr wrap="square" anchor="t" lIns="0" rIns="0" tIns="0" bIns="0">
+          <a:bodyPr wrap="square" lIns="0" tIns="0" rIns="0" bIns="0" anchor="t">
             <a:spAutoFit/>
           </a:bodyPr>
           <a:lstStyle/>
@@ -14494,7 +14660,7 @@
           <a:noFill/>
         </p:spPr>
         <p:txBody>
-          <a:bodyPr wrap="square" anchor="t" lIns="0" rIns="0" tIns="0" bIns="0">
+          <a:bodyPr wrap="square" lIns="0" tIns="0" rIns="0" bIns="0" anchor="t">
             <a:spAutoFit/>
           </a:bodyPr>
           <a:lstStyle/>
@@ -14554,6 +14720,7 @@
           <a:lstStyle/>
           <a:p>
             <a:pPr algn="ctr"/>
+            <a:endParaRPr/>
           </a:p>
         </p:txBody>
       </p:sp>
@@ -14597,6 +14764,7 @@
           <a:lstStyle/>
           <a:p>
             <a:pPr algn="ctr"/>
+            <a:endParaRPr/>
           </a:p>
         </p:txBody>
       </p:sp>
@@ -14617,7 +14785,7 @@
           <a:noFill/>
         </p:spPr>
         <p:txBody>
-          <a:bodyPr wrap="square" anchor="t" lIns="0" rIns="0" tIns="0" bIns="0">
+          <a:bodyPr wrap="square" lIns="0" tIns="0" rIns="0" bIns="0" anchor="t">
             <a:spAutoFit/>
           </a:bodyPr>
           <a:lstStyle/>
@@ -14652,7 +14820,7 @@
           <a:noFill/>
         </p:spPr>
         <p:txBody>
-          <a:bodyPr wrap="square" anchor="t" lIns="0" rIns="0" tIns="0" bIns="0">
+          <a:bodyPr wrap="square" lIns="0" tIns="0" rIns="0" bIns="0" anchor="t">
             <a:spAutoFit/>
           </a:bodyPr>
           <a:lstStyle/>
@@ -14712,6 +14880,7 @@
           <a:lstStyle/>
           <a:p>
             <a:pPr algn="ctr"/>
+            <a:endParaRPr/>
           </a:p>
         </p:txBody>
       </p:sp>
@@ -14755,6 +14924,7 @@
           <a:lstStyle/>
           <a:p>
             <a:pPr algn="ctr"/>
+            <a:endParaRPr/>
           </a:p>
         </p:txBody>
       </p:sp>
@@ -14775,7 +14945,7 @@
           <a:noFill/>
         </p:spPr>
         <p:txBody>
-          <a:bodyPr wrap="square" anchor="t" lIns="0" rIns="0" tIns="0" bIns="0">
+          <a:bodyPr wrap="square" lIns="0" tIns="0" rIns="0" bIns="0" anchor="t">
             <a:spAutoFit/>
           </a:bodyPr>
           <a:lstStyle/>
@@ -14810,7 +14980,7 @@
           <a:noFill/>
         </p:spPr>
         <p:txBody>
-          <a:bodyPr wrap="square" anchor="t" lIns="0" rIns="0" tIns="0" bIns="0">
+          <a:bodyPr wrap="square" lIns="0" tIns="0" rIns="0" bIns="0" anchor="t">
             <a:spAutoFit/>
           </a:bodyPr>
           <a:lstStyle/>
@@ -14870,6 +15040,7 @@
           <a:lstStyle/>
           <a:p>
             <a:pPr algn="ctr"/>
+            <a:endParaRPr/>
           </a:p>
         </p:txBody>
       </p:sp>
@@ -14913,6 +15084,7 @@
           <a:lstStyle/>
           <a:p>
             <a:pPr algn="ctr"/>
+            <a:endParaRPr/>
           </a:p>
         </p:txBody>
       </p:sp>
@@ -14933,7 +15105,7 @@
           <a:noFill/>
         </p:spPr>
         <p:txBody>
-          <a:bodyPr wrap="square" anchor="t" lIns="0" rIns="0" tIns="0" bIns="0">
+          <a:bodyPr wrap="square" lIns="0" tIns="0" rIns="0" bIns="0" anchor="t">
             <a:spAutoFit/>
           </a:bodyPr>
           <a:lstStyle/>
@@ -14968,7 +15140,7 @@
           <a:noFill/>
         </p:spPr>
         <p:txBody>
-          <a:bodyPr wrap="square" anchor="t" lIns="0" rIns="0" tIns="0" bIns="0">
+          <a:bodyPr wrap="square" lIns="0" tIns="0" rIns="0" bIns="0" anchor="t">
             <a:spAutoFit/>
           </a:bodyPr>
           <a:lstStyle/>
@@ -15028,6 +15200,7 @@
           <a:lstStyle/>
           <a:p>
             <a:pPr algn="ctr"/>
+            <a:endParaRPr/>
           </a:p>
         </p:txBody>
       </p:sp>
@@ -15071,6 +15244,7 @@
           <a:lstStyle/>
           <a:p>
             <a:pPr algn="ctr"/>
+            <a:endParaRPr/>
           </a:p>
         </p:txBody>
       </p:sp>
@@ -15091,7 +15265,7 @@
           <a:noFill/>
         </p:spPr>
         <p:txBody>
-          <a:bodyPr wrap="square" anchor="t" lIns="0" rIns="0" tIns="0" bIns="0">
+          <a:bodyPr wrap="square" lIns="0" tIns="0" rIns="0" bIns="0" anchor="t">
             <a:spAutoFit/>
           </a:bodyPr>
           <a:lstStyle/>
@@ -15126,7 +15300,7 @@
           <a:noFill/>
         </p:spPr>
         <p:txBody>
-          <a:bodyPr wrap="square" anchor="t" lIns="0" rIns="0" tIns="0" bIns="0">
+          <a:bodyPr wrap="square" lIns="0" tIns="0" rIns="0" bIns="0" anchor="t">
             <a:spAutoFit/>
           </a:bodyPr>
           <a:lstStyle/>
@@ -15186,6 +15360,7 @@
           <a:lstStyle/>
           <a:p>
             <a:pPr algn="ctr"/>
+            <a:endParaRPr/>
           </a:p>
         </p:txBody>
       </p:sp>
@@ -15229,6 +15404,7 @@
           <a:lstStyle/>
           <a:p>
             <a:pPr algn="ctr"/>
+            <a:endParaRPr/>
           </a:p>
         </p:txBody>
       </p:sp>
@@ -15249,7 +15425,7 @@
           <a:noFill/>
         </p:spPr>
         <p:txBody>
-          <a:bodyPr wrap="square" anchor="t" lIns="0" rIns="0" tIns="0" bIns="0">
+          <a:bodyPr wrap="square" lIns="0" tIns="0" rIns="0" bIns="0" anchor="t">
             <a:spAutoFit/>
           </a:bodyPr>
           <a:lstStyle/>
@@ -15284,7 +15460,7 @@
           <a:noFill/>
         </p:spPr>
         <p:txBody>
-          <a:bodyPr wrap="square" anchor="t" lIns="0" rIns="0" tIns="0" bIns="0">
+          <a:bodyPr wrap="square" lIns="0" tIns="0" rIns="0" bIns="0" anchor="t">
             <a:spAutoFit/>
           </a:bodyPr>
           <a:lstStyle/>
@@ -15344,6 +15520,7 @@
           <a:lstStyle/>
           <a:p>
             <a:pPr algn="ctr"/>
+            <a:endParaRPr/>
           </a:p>
         </p:txBody>
       </p:sp>
@@ -15387,6 +15564,7 @@
           <a:lstStyle/>
           <a:p>
             <a:pPr algn="ctr"/>
+            <a:endParaRPr/>
           </a:p>
         </p:txBody>
       </p:sp>
@@ -15407,7 +15585,7 @@
           <a:noFill/>
         </p:spPr>
         <p:txBody>
-          <a:bodyPr wrap="square" anchor="t" lIns="0" rIns="0" tIns="0" bIns="0">
+          <a:bodyPr wrap="square" lIns="0" tIns="0" rIns="0" bIns="0" anchor="t">
             <a:spAutoFit/>
           </a:bodyPr>
           <a:lstStyle/>
@@ -15442,7 +15620,7 @@
           <a:noFill/>
         </p:spPr>
         <p:txBody>
-          <a:bodyPr wrap="square" anchor="t" lIns="0" rIns="0" tIns="0" bIns="0">
+          <a:bodyPr wrap="square" lIns="0" tIns="0" rIns="0" bIns="0" anchor="t">
             <a:spAutoFit/>
           </a:bodyPr>
           <a:lstStyle/>
@@ -15502,6 +15680,7 @@
           <a:lstStyle/>
           <a:p>
             <a:pPr algn="ctr"/>
+            <a:endParaRPr/>
           </a:p>
         </p:txBody>
       </p:sp>
@@ -15545,6 +15724,7 @@
           <a:lstStyle/>
           <a:p>
             <a:pPr algn="ctr"/>
+            <a:endParaRPr/>
           </a:p>
         </p:txBody>
       </p:sp>
@@ -15565,7 +15745,7 @@
           <a:noFill/>
         </p:spPr>
         <p:txBody>
-          <a:bodyPr wrap="square" anchor="t" lIns="0" rIns="0" tIns="0" bIns="0">
+          <a:bodyPr wrap="square" lIns="0" tIns="0" rIns="0" bIns="0" anchor="t">
             <a:spAutoFit/>
           </a:bodyPr>
           <a:lstStyle/>
@@ -15600,7 +15780,7 @@
           <a:noFill/>
         </p:spPr>
         <p:txBody>
-          <a:bodyPr wrap="square" anchor="t" lIns="0" rIns="0" tIns="0" bIns="0">
+          <a:bodyPr wrap="square" lIns="0" tIns="0" rIns="0" bIns="0" anchor="t">
             <a:spAutoFit/>
           </a:bodyPr>
           <a:lstStyle/>
@@ -15660,6 +15840,7 @@
           <a:lstStyle/>
           <a:p>
             <a:pPr algn="ctr"/>
+            <a:endParaRPr/>
           </a:p>
         </p:txBody>
       </p:sp>
@@ -15703,6 +15884,7 @@
           <a:lstStyle/>
           <a:p>
             <a:pPr algn="ctr"/>
+            <a:endParaRPr/>
           </a:p>
         </p:txBody>
       </p:sp>
@@ -15723,7 +15905,7 @@
           <a:noFill/>
         </p:spPr>
         <p:txBody>
-          <a:bodyPr wrap="square" anchor="t" lIns="0" rIns="0" tIns="0" bIns="0">
+          <a:bodyPr wrap="square" lIns="0" tIns="0" rIns="0" bIns="0" anchor="t">
             <a:spAutoFit/>
           </a:bodyPr>
           <a:lstStyle/>
@@ -15758,7 +15940,7 @@
           <a:noFill/>
         </p:spPr>
         <p:txBody>
-          <a:bodyPr wrap="square" anchor="t" lIns="0" rIns="0" tIns="0" bIns="0">
+          <a:bodyPr wrap="square" lIns="0" tIns="0" rIns="0" bIns="0" anchor="t">
             <a:spAutoFit/>
           </a:bodyPr>
           <a:lstStyle/>
@@ -15816,6 +15998,7 @@
           <a:lstStyle/>
           <a:p>
             <a:pPr algn="ctr"/>
+            <a:endParaRPr/>
           </a:p>
         </p:txBody>
       </p:sp>
@@ -15836,7 +16019,7 @@
           <a:noFill/>
         </p:spPr>
         <p:txBody>
-          <a:bodyPr wrap="square" anchor="t" lIns="0" rIns="0" tIns="0" bIns="0">
+          <a:bodyPr wrap="square" lIns="0" tIns="0" rIns="0" bIns="0" anchor="t">
             <a:spAutoFit/>
           </a:bodyPr>
           <a:lstStyle/>
@@ -15871,7 +16054,7 @@
           <a:noFill/>
         </p:spPr>
         <p:txBody>
-          <a:bodyPr wrap="square" anchor="t" lIns="0" rIns="0" tIns="0" bIns="0">
+          <a:bodyPr wrap="square" lIns="0" tIns="0" rIns="0" bIns="0" anchor="t">
             <a:spAutoFit/>
           </a:bodyPr>
           <a:lstStyle/>
@@ -15906,7 +16089,7 @@
           <a:noFill/>
         </p:spPr>
         <p:txBody>
-          <a:bodyPr wrap="square" anchor="t" lIns="0" rIns="0" tIns="0" bIns="0">
+          <a:bodyPr wrap="square" lIns="0" tIns="0" rIns="0" bIns="0" anchor="t">
             <a:spAutoFit/>
           </a:bodyPr>
           <a:lstStyle/>
@@ -15941,7 +16124,7 @@
           <a:noFill/>
         </p:spPr>
         <p:txBody>
-          <a:bodyPr wrap="square" anchor="t" lIns="0" rIns="0" tIns="0" bIns="0">
+          <a:bodyPr wrap="square" lIns="0" tIns="0" rIns="0" bIns="0" anchor="t">
             <a:spAutoFit/>
           </a:bodyPr>
           <a:lstStyle/>
@@ -15968,7 +16151,7 @@
 </file>
 
 <file path=ppt/slides/slide8.xml><?xml version="1.0" encoding="utf-8"?>
-<p:sld xmlns:a="http://schemas.openxmlformats.org/drawingml/2006/main" xmlns:p="http://schemas.openxmlformats.org/presentationml/2006/main" xmlns:r="http://schemas.openxmlformats.org/officeDocument/2006/relationships">
+<p:sld xmlns:a="http://schemas.openxmlformats.org/drawingml/2006/main" xmlns:r="http://schemas.openxmlformats.org/officeDocument/2006/relationships" xmlns:p="http://schemas.openxmlformats.org/presentationml/2006/main">
   <p:cSld>
     <p:spTree>
       <p:nvGrpSpPr>
@@ -15976,7 +16159,14 @@
         <p:cNvGrpSpPr/>
         <p:nvPr/>
       </p:nvGrpSpPr>
-      <p:grpSpPr/>
+      <p:grpSpPr>
+        <a:xfrm>
+          <a:off x="0" y="0"/>
+          <a:ext cx="0" cy="0"/>
+          <a:chOff x="0" y="0"/>
+          <a:chExt cx="0" cy="0"/>
+        </a:xfrm>
+      </p:grpSpPr>
       <p:sp>
         <p:nvSpPr>
           <p:cNvPr id="2" name="Rectangle 1"/>
@@ -16017,6 +16207,7 @@
           <a:lstStyle/>
           <a:p>
             <a:pPr algn="ctr"/>
+            <a:endParaRPr/>
           </a:p>
         </p:txBody>
       </p:sp>
@@ -16060,6 +16251,7 @@
           <a:lstStyle/>
           <a:p>
             <a:pPr algn="ctr"/>
+            <a:endParaRPr/>
           </a:p>
         </p:txBody>
       </p:sp>
@@ -16099,7 +16291,7 @@
           </a:fontRef>
         </p:style>
         <p:txBody>
-          <a:bodyPr rtlCol="0" anchor="ctr" lIns="0" rIns="0" tIns="0" bIns="0"/>
+          <a:bodyPr lIns="0" tIns="0" rIns="0" bIns="0" rtlCol="0" anchor="ctr"/>
           <a:lstStyle/>
           <a:p>
             <a:pPr algn="ctr"/>
@@ -16132,7 +16324,7 @@
           <a:noFill/>
         </p:spPr>
         <p:txBody>
-          <a:bodyPr wrap="square" anchor="t" lIns="0" rIns="0" tIns="0" bIns="0">
+          <a:bodyPr wrap="square" lIns="0" tIns="0" rIns="0" bIns="0" anchor="t">
             <a:spAutoFit/>
           </a:bodyPr>
           <a:lstStyle/>
@@ -16167,7 +16359,7 @@
           <a:noFill/>
         </p:spPr>
         <p:txBody>
-          <a:bodyPr wrap="square" anchor="t" lIns="0" rIns="0" tIns="0" bIns="0">
+          <a:bodyPr wrap="square" lIns="0" tIns="0" rIns="0" bIns="0" anchor="t">
             <a:spAutoFit/>
           </a:bodyPr>
           <a:lstStyle/>
@@ -16202,7 +16394,7 @@
           <a:noFill/>
         </p:spPr>
         <p:txBody>
-          <a:bodyPr wrap="square" anchor="t" lIns="0" rIns="0" tIns="0" bIns="0">
+          <a:bodyPr wrap="square" lIns="0" tIns="0" rIns="0" bIns="0" anchor="t">
             <a:spAutoFit/>
           </a:bodyPr>
           <a:lstStyle/>
@@ -16237,7 +16429,7 @@
           <a:noFill/>
         </p:spPr>
         <p:txBody>
-          <a:bodyPr wrap="square" anchor="t" lIns="0" rIns="0" tIns="0" bIns="0">
+          <a:bodyPr wrap="square" lIns="0" tIns="0" rIns="0" bIns="0" anchor="t">
             <a:spAutoFit/>
           </a:bodyPr>
           <a:lstStyle/>
@@ -16297,6 +16489,7 @@
           <a:lstStyle/>
           <a:p>
             <a:pPr algn="ctr"/>
+            <a:endParaRPr/>
           </a:p>
         </p:txBody>
       </p:sp>
@@ -16340,6 +16533,7 @@
           <a:lstStyle/>
           <a:p>
             <a:pPr algn="ctr"/>
+            <a:endParaRPr/>
           </a:p>
         </p:txBody>
       </p:sp>
@@ -16360,7 +16554,7 @@
           <a:noFill/>
         </p:spPr>
         <p:txBody>
-          <a:bodyPr wrap="square" anchor="t" lIns="0" rIns="0" tIns="0" bIns="0">
+          <a:bodyPr wrap="square" lIns="0" tIns="0" rIns="0" bIns="0" anchor="t">
             <a:spAutoFit/>
           </a:bodyPr>
           <a:lstStyle/>
@@ -16395,7 +16589,7 @@
           <a:noFill/>
         </p:spPr>
         <p:txBody>
-          <a:bodyPr wrap="square" anchor="t" lIns="0" rIns="0" tIns="0" bIns="0">
+          <a:bodyPr wrap="square" lIns="0" tIns="0" rIns="0" bIns="0" anchor="t">
             <a:spAutoFit/>
           </a:bodyPr>
           <a:lstStyle/>
@@ -16430,7 +16624,7 @@
           <a:noFill/>
         </p:spPr>
         <p:txBody>
-          <a:bodyPr wrap="square" anchor="t" lIns="0" rIns="0" tIns="0" bIns="0">
+          <a:bodyPr wrap="square" lIns="0" tIns="0" rIns="0" bIns="0" anchor="t">
             <a:spAutoFit/>
           </a:bodyPr>
           <a:lstStyle/>
@@ -16490,6 +16684,7 @@
           <a:lstStyle/>
           <a:p>
             <a:pPr algn="ctr"/>
+            <a:endParaRPr/>
           </a:p>
         </p:txBody>
       </p:sp>
@@ -16533,6 +16728,7 @@
           <a:lstStyle/>
           <a:p>
             <a:pPr algn="ctr"/>
+            <a:endParaRPr/>
           </a:p>
         </p:txBody>
       </p:sp>
@@ -16553,7 +16749,7 @@
           <a:noFill/>
         </p:spPr>
         <p:txBody>
-          <a:bodyPr wrap="square" anchor="t" lIns="0" rIns="0" tIns="0" bIns="0">
+          <a:bodyPr wrap="square" lIns="0" tIns="0" rIns="0" bIns="0" anchor="t">
             <a:spAutoFit/>
           </a:bodyPr>
           <a:lstStyle/>
@@ -16588,7 +16784,7 @@
           <a:noFill/>
         </p:spPr>
         <p:txBody>
-          <a:bodyPr wrap="square" anchor="t" lIns="0" rIns="0" tIns="0" bIns="0">
+          <a:bodyPr wrap="square" lIns="0" tIns="0" rIns="0" bIns="0" anchor="t">
             <a:spAutoFit/>
           </a:bodyPr>
           <a:lstStyle/>
@@ -16623,7 +16819,7 @@
           <a:noFill/>
         </p:spPr>
         <p:txBody>
-          <a:bodyPr wrap="square" anchor="t" lIns="0" rIns="0" tIns="0" bIns="0">
+          <a:bodyPr wrap="square" lIns="0" tIns="0" rIns="0" bIns="0" anchor="t">
             <a:spAutoFit/>
           </a:bodyPr>
           <a:lstStyle/>
@@ -16683,6 +16879,7 @@
           <a:lstStyle/>
           <a:p>
             <a:pPr algn="ctr"/>
+            <a:endParaRPr/>
           </a:p>
         </p:txBody>
       </p:sp>
@@ -16726,6 +16923,7 @@
           <a:lstStyle/>
           <a:p>
             <a:pPr algn="ctr"/>
+            <a:endParaRPr/>
           </a:p>
         </p:txBody>
       </p:sp>
@@ -16746,7 +16944,7 @@
           <a:noFill/>
         </p:spPr>
         <p:txBody>
-          <a:bodyPr wrap="square" anchor="t" lIns="0" rIns="0" tIns="0" bIns="0">
+          <a:bodyPr wrap="square" lIns="0" tIns="0" rIns="0" bIns="0" anchor="t">
             <a:spAutoFit/>
           </a:bodyPr>
           <a:lstStyle/>
@@ -16781,7 +16979,7 @@
           <a:noFill/>
         </p:spPr>
         <p:txBody>
-          <a:bodyPr wrap="square" anchor="t" lIns="0" rIns="0" tIns="0" bIns="0">
+          <a:bodyPr wrap="square" lIns="0" tIns="0" rIns="0" bIns="0" anchor="t">
             <a:spAutoFit/>
           </a:bodyPr>
           <a:lstStyle/>
@@ -16816,7 +17014,7 @@
           <a:noFill/>
         </p:spPr>
         <p:txBody>
-          <a:bodyPr wrap="square" anchor="t" lIns="0" rIns="0" tIns="0" bIns="0">
+          <a:bodyPr wrap="square" lIns="0" tIns="0" rIns="0" bIns="0" anchor="t">
             <a:spAutoFit/>
           </a:bodyPr>
           <a:lstStyle/>
@@ -16876,6 +17074,7 @@
           <a:lstStyle/>
           <a:p>
             <a:pPr algn="ctr"/>
+            <a:endParaRPr/>
           </a:p>
         </p:txBody>
       </p:sp>
@@ -16919,6 +17118,7 @@
           <a:lstStyle/>
           <a:p>
             <a:pPr algn="ctr"/>
+            <a:endParaRPr/>
           </a:p>
         </p:txBody>
       </p:sp>
@@ -16939,7 +17139,7 @@
           <a:noFill/>
         </p:spPr>
         <p:txBody>
-          <a:bodyPr wrap="square" anchor="t" lIns="0" rIns="0" tIns="0" bIns="0">
+          <a:bodyPr wrap="square" lIns="0" tIns="0" rIns="0" bIns="0" anchor="t">
             <a:spAutoFit/>
           </a:bodyPr>
           <a:lstStyle/>
@@ -16974,7 +17174,7 @@
           <a:noFill/>
         </p:spPr>
         <p:txBody>
-          <a:bodyPr wrap="square" anchor="t" lIns="0" rIns="0" tIns="0" bIns="0">
+          <a:bodyPr wrap="square" lIns="0" tIns="0" rIns="0" bIns="0" anchor="t">
             <a:spAutoFit/>
           </a:bodyPr>
           <a:lstStyle/>
@@ -17009,7 +17209,7 @@
           <a:noFill/>
         </p:spPr>
         <p:txBody>
-          <a:bodyPr wrap="square" anchor="t" lIns="0" rIns="0" tIns="0" bIns="0">
+          <a:bodyPr wrap="square" lIns="0" tIns="0" rIns="0" bIns="0" anchor="t">
             <a:spAutoFit/>
           </a:bodyPr>
           <a:lstStyle/>
@@ -17069,6 +17269,7 @@
           <a:lstStyle/>
           <a:p>
             <a:pPr algn="ctr"/>
+            <a:endParaRPr/>
           </a:p>
         </p:txBody>
       </p:sp>
@@ -17112,6 +17313,7 @@
           <a:lstStyle/>
           <a:p>
             <a:pPr algn="ctr"/>
+            <a:endParaRPr/>
           </a:p>
         </p:txBody>
       </p:sp>
@@ -17132,7 +17334,7 @@
           <a:noFill/>
         </p:spPr>
         <p:txBody>
-          <a:bodyPr wrap="square" anchor="t" lIns="0" rIns="0" tIns="0" bIns="0">
+          <a:bodyPr wrap="square" lIns="0" tIns="0" rIns="0" bIns="0" anchor="t">
             <a:spAutoFit/>
           </a:bodyPr>
           <a:lstStyle/>
@@ -17167,7 +17369,7 @@
           <a:noFill/>
         </p:spPr>
         <p:txBody>
-          <a:bodyPr wrap="square" anchor="t" lIns="0" rIns="0" tIns="0" bIns="0">
+          <a:bodyPr wrap="square" lIns="0" tIns="0" rIns="0" bIns="0" anchor="t">
             <a:spAutoFit/>
           </a:bodyPr>
           <a:lstStyle/>
@@ -17202,7 +17404,7 @@
           <a:noFill/>
         </p:spPr>
         <p:txBody>
-          <a:bodyPr wrap="square" anchor="t" lIns="0" rIns="0" tIns="0" bIns="0">
+          <a:bodyPr wrap="square" lIns="0" tIns="0" rIns="0" bIns="0" anchor="t">
             <a:spAutoFit/>
           </a:bodyPr>
           <a:lstStyle/>
@@ -17237,7 +17439,7 @@
           <a:noFill/>
         </p:spPr>
         <p:txBody>
-          <a:bodyPr wrap="square" anchor="t" lIns="0" rIns="0" tIns="0" bIns="0">
+          <a:bodyPr wrap="square" lIns="0" tIns="0" rIns="0" bIns="0" anchor="t">
             <a:spAutoFit/>
           </a:bodyPr>
           <a:lstStyle/>
@@ -17295,6 +17497,7 @@
           <a:lstStyle/>
           <a:p>
             <a:pPr algn="ctr"/>
+            <a:endParaRPr/>
           </a:p>
         </p:txBody>
       </p:sp>
@@ -17315,7 +17518,7 @@
           <a:noFill/>
         </p:spPr>
         <p:txBody>
-          <a:bodyPr wrap="square" anchor="t" lIns="0" rIns="0" tIns="0" bIns="0">
+          <a:bodyPr wrap="square" lIns="0" tIns="0" rIns="0" bIns="0" anchor="t">
             <a:spAutoFit/>
           </a:bodyPr>
           <a:lstStyle/>
@@ -17373,6 +17576,7 @@
           <a:lstStyle/>
           <a:p>
             <a:pPr algn="ctr"/>
+            <a:endParaRPr/>
           </a:p>
         </p:txBody>
       </p:sp>
@@ -17393,7 +17597,7 @@
           <a:noFill/>
         </p:spPr>
         <p:txBody>
-          <a:bodyPr wrap="square" anchor="t" lIns="0" rIns="0" tIns="0" bIns="0">
+          <a:bodyPr wrap="square" lIns="0" tIns="0" rIns="0" bIns="0" anchor="t">
             <a:spAutoFit/>
           </a:bodyPr>
           <a:lstStyle/>
@@ -17451,6 +17655,7 @@
           <a:lstStyle/>
           <a:p>
             <a:pPr algn="ctr"/>
+            <a:endParaRPr/>
           </a:p>
         </p:txBody>
       </p:sp>
@@ -17471,7 +17676,7 @@
           <a:noFill/>
         </p:spPr>
         <p:txBody>
-          <a:bodyPr wrap="square" anchor="t" lIns="0" rIns="0" tIns="0" bIns="0">
+          <a:bodyPr wrap="square" lIns="0" tIns="0" rIns="0" bIns="0" anchor="t">
             <a:spAutoFit/>
           </a:bodyPr>
           <a:lstStyle/>
@@ -17529,6 +17734,7 @@
           <a:lstStyle/>
           <a:p>
             <a:pPr algn="ctr"/>
+            <a:endParaRPr/>
           </a:p>
         </p:txBody>
       </p:sp>
@@ -17549,7 +17755,7 @@
           <a:noFill/>
         </p:spPr>
         <p:txBody>
-          <a:bodyPr wrap="square" anchor="t" lIns="0" rIns="0" tIns="0" bIns="0">
+          <a:bodyPr wrap="square" lIns="0" tIns="0" rIns="0" bIns="0" anchor="t">
             <a:spAutoFit/>
           </a:bodyPr>
           <a:lstStyle/>
@@ -17607,6 +17813,7 @@
           <a:lstStyle/>
           <a:p>
             <a:pPr algn="ctr"/>
+            <a:endParaRPr/>
           </a:p>
         </p:txBody>
       </p:sp>
@@ -17627,7 +17834,7 @@
           <a:noFill/>
         </p:spPr>
         <p:txBody>
-          <a:bodyPr wrap="square" anchor="t" lIns="0" rIns="0" tIns="0" bIns="0">
+          <a:bodyPr wrap="square" lIns="0" tIns="0" rIns="0" bIns="0" anchor="t">
             <a:spAutoFit/>
           </a:bodyPr>
           <a:lstStyle/>
@@ -17685,6 +17892,7 @@
           <a:lstStyle/>
           <a:p>
             <a:pPr algn="ctr"/>
+            <a:endParaRPr/>
           </a:p>
         </p:txBody>
       </p:sp>
@@ -17705,7 +17913,7 @@
           <a:noFill/>
         </p:spPr>
         <p:txBody>
-          <a:bodyPr wrap="square" anchor="t" lIns="0" rIns="0" tIns="0" bIns="0">
+          <a:bodyPr wrap="square" lIns="0" tIns="0" rIns="0" bIns="0" anchor="t">
             <a:spAutoFit/>
           </a:bodyPr>
           <a:lstStyle/>
@@ -17763,6 +17971,7 @@
           <a:lstStyle/>
           <a:p>
             <a:pPr algn="ctr"/>
+            <a:endParaRPr/>
           </a:p>
         </p:txBody>
       </p:sp>
@@ -17783,7 +17992,7 @@
           <a:noFill/>
         </p:spPr>
         <p:txBody>
-          <a:bodyPr wrap="square" anchor="t" lIns="0" rIns="0" tIns="0" bIns="0">
+          <a:bodyPr wrap="square" lIns="0" tIns="0" rIns="0" bIns="0" anchor="t">
             <a:spAutoFit/>
           </a:bodyPr>
           <a:lstStyle/>
@@ -17841,6 +18050,7 @@
           <a:lstStyle/>
           <a:p>
             <a:pPr algn="ctr"/>
+            <a:endParaRPr/>
           </a:p>
         </p:txBody>
       </p:sp>
@@ -17861,7 +18071,7 @@
           <a:noFill/>
         </p:spPr>
         <p:txBody>
-          <a:bodyPr wrap="square" anchor="t" lIns="0" rIns="0" tIns="0" bIns="0">
+          <a:bodyPr wrap="square" lIns="0" tIns="0" rIns="0" bIns="0" anchor="t">
             <a:spAutoFit/>
           </a:bodyPr>
           <a:lstStyle/>
@@ -17896,7 +18106,7 @@
           <a:noFill/>
         </p:spPr>
         <p:txBody>
-          <a:bodyPr wrap="square" anchor="t" lIns="0" rIns="0" tIns="0" bIns="0">
+          <a:bodyPr wrap="square" lIns="0" tIns="0" rIns="0" bIns="0" anchor="t">
             <a:spAutoFit/>
           </a:bodyPr>
           <a:lstStyle/>
@@ -17931,7 +18141,7 @@
           <a:noFill/>
         </p:spPr>
         <p:txBody>
-          <a:bodyPr wrap="square" anchor="t" lIns="0" rIns="0" tIns="0" bIns="0">
+          <a:bodyPr wrap="square" lIns="0" tIns="0" rIns="0" bIns="0" anchor="t">
             <a:spAutoFit/>
           </a:bodyPr>
           <a:lstStyle/>
@@ -17958,7 +18168,7 @@
 </file>
 
 <file path=ppt/slides/slide9.xml><?xml version="1.0" encoding="utf-8"?>
-<p:sld xmlns:a="http://schemas.openxmlformats.org/drawingml/2006/main" xmlns:p="http://schemas.openxmlformats.org/presentationml/2006/main" xmlns:r="http://schemas.openxmlformats.org/officeDocument/2006/relationships">
+<p:sld xmlns:a="http://schemas.openxmlformats.org/drawingml/2006/main" xmlns:r="http://schemas.openxmlformats.org/officeDocument/2006/relationships" xmlns:p="http://schemas.openxmlformats.org/presentationml/2006/main">
   <p:cSld>
     <p:spTree>
       <p:nvGrpSpPr>
@@ -17966,7 +18176,14 @@
         <p:cNvGrpSpPr/>
         <p:nvPr/>
       </p:nvGrpSpPr>
-      <p:grpSpPr/>
+      <p:grpSpPr>
+        <a:xfrm>
+          <a:off x="0" y="0"/>
+          <a:ext cx="0" cy="0"/>
+          <a:chOff x="0" y="0"/>
+          <a:chExt cx="0" cy="0"/>
+        </a:xfrm>
+      </p:grpSpPr>
       <p:sp>
         <p:nvSpPr>
           <p:cNvPr id="2" name="Rectangle 1"/>
@@ -18007,6 +18224,7 @@
           <a:lstStyle/>
           <a:p>
             <a:pPr algn="ctr"/>
+            <a:endParaRPr/>
           </a:p>
         </p:txBody>
       </p:sp>
@@ -18050,6 +18268,7 @@
           <a:lstStyle/>
           <a:p>
             <a:pPr algn="ctr"/>
+            <a:endParaRPr/>
           </a:p>
         </p:txBody>
       </p:sp>
@@ -18089,7 +18308,7 @@
           </a:fontRef>
         </p:style>
         <p:txBody>
-          <a:bodyPr rtlCol="0" anchor="ctr" lIns="0" rIns="0" tIns="0" bIns="0"/>
+          <a:bodyPr lIns="0" tIns="0" rIns="0" bIns="0" rtlCol="0" anchor="ctr"/>
           <a:lstStyle/>
           <a:p>
             <a:pPr algn="ctr"/>
@@ -18122,7 +18341,7 @@
           <a:noFill/>
         </p:spPr>
         <p:txBody>
-          <a:bodyPr wrap="square" anchor="t" lIns="0" rIns="0" tIns="0" bIns="0">
+          <a:bodyPr wrap="square" lIns="0" tIns="0" rIns="0" bIns="0" anchor="t">
             <a:spAutoFit/>
           </a:bodyPr>
           <a:lstStyle/>
@@ -18157,7 +18376,7 @@
           <a:noFill/>
         </p:spPr>
         <p:txBody>
-          <a:bodyPr wrap="square" anchor="t" lIns="0" rIns="0" tIns="0" bIns="0">
+          <a:bodyPr wrap="square" lIns="0" tIns="0" rIns="0" bIns="0" anchor="t">
             <a:spAutoFit/>
           </a:bodyPr>
           <a:lstStyle/>
@@ -18192,7 +18411,7 @@
           <a:noFill/>
         </p:spPr>
         <p:txBody>
-          <a:bodyPr wrap="square" anchor="t" lIns="0" rIns="0" tIns="0" bIns="0">
+          <a:bodyPr wrap="square" lIns="0" tIns="0" rIns="0" bIns="0" anchor="t">
             <a:spAutoFit/>
           </a:bodyPr>
           <a:lstStyle/>
@@ -18227,7 +18446,7 @@
           <a:noFill/>
         </p:spPr>
         <p:txBody>
-          <a:bodyPr wrap="square" anchor="t" lIns="0" rIns="0" tIns="0" bIns="0">
+          <a:bodyPr wrap="square" lIns="0" tIns="0" rIns="0" bIns="0" anchor="t">
             <a:spAutoFit/>
           </a:bodyPr>
           <a:lstStyle/>
@@ -18287,6 +18506,7 @@
           <a:lstStyle/>
           <a:p>
             <a:pPr algn="ctr"/>
+            <a:endParaRPr/>
           </a:p>
         </p:txBody>
       </p:sp>
@@ -18330,6 +18550,7 @@
           <a:lstStyle/>
           <a:p>
             <a:pPr algn="ctr"/>
+            <a:endParaRPr/>
           </a:p>
         </p:txBody>
       </p:sp>
@@ -18373,6 +18594,7 @@
           <a:lstStyle/>
           <a:p>
             <a:pPr algn="ctr"/>
+            <a:endParaRPr/>
           </a:p>
         </p:txBody>
       </p:sp>
@@ -18393,7 +18615,7 @@
           <a:noFill/>
         </p:spPr>
         <p:txBody>
-          <a:bodyPr wrap="square" anchor="t" lIns="0" rIns="0" tIns="0" bIns="0">
+          <a:bodyPr wrap="square" lIns="0" tIns="0" rIns="0" bIns="0" anchor="t">
             <a:spAutoFit/>
           </a:bodyPr>
           <a:lstStyle/>
@@ -18428,7 +18650,7 @@
           <a:noFill/>
         </p:spPr>
         <p:txBody>
-          <a:bodyPr wrap="square" anchor="t" lIns="0" rIns="0" tIns="0" bIns="0">
+          <a:bodyPr wrap="square" lIns="0" tIns="0" rIns="0" bIns="0" anchor="t">
             <a:spAutoFit/>
           </a:bodyPr>
           <a:lstStyle/>
@@ -18463,7 +18685,7 @@
           <a:noFill/>
         </p:spPr>
         <p:txBody>
-          <a:bodyPr wrap="square" anchor="t" lIns="0" rIns="0" tIns="0" bIns="0">
+          <a:bodyPr wrap="square" lIns="0" tIns="0" rIns="0" bIns="0" anchor="t">
             <a:spAutoFit/>
           </a:bodyPr>
           <a:lstStyle/>
@@ -18498,7 +18720,7 @@
           <a:noFill/>
         </p:spPr>
         <p:txBody>
-          <a:bodyPr wrap="square" anchor="t" lIns="0" rIns="0" tIns="0" bIns="0">
+          <a:bodyPr wrap="square" lIns="0" tIns="0" rIns="0" bIns="0" anchor="t">
             <a:spAutoFit/>
           </a:bodyPr>
           <a:lstStyle/>
@@ -18558,6 +18780,7 @@
           <a:lstStyle/>
           <a:p>
             <a:pPr algn="ctr"/>
+            <a:endParaRPr/>
           </a:p>
         </p:txBody>
       </p:sp>
@@ -18601,6 +18824,7 @@
           <a:lstStyle/>
           <a:p>
             <a:pPr algn="ctr"/>
+            <a:endParaRPr/>
           </a:p>
         </p:txBody>
       </p:sp>
@@ -18644,6 +18868,7 @@
           <a:lstStyle/>
           <a:p>
             <a:pPr algn="ctr"/>
+            <a:endParaRPr/>
           </a:p>
         </p:txBody>
       </p:sp>
@@ -18664,7 +18889,7 @@
           <a:noFill/>
         </p:spPr>
         <p:txBody>
-          <a:bodyPr wrap="square" anchor="t" lIns="0" rIns="0" tIns="0" bIns="0">
+          <a:bodyPr wrap="square" lIns="0" tIns="0" rIns="0" bIns="0" anchor="t">
             <a:spAutoFit/>
           </a:bodyPr>
           <a:lstStyle/>
@@ -18699,7 +18924,7 @@
           <a:noFill/>
         </p:spPr>
         <p:txBody>
-          <a:bodyPr wrap="square" anchor="t" lIns="0" rIns="0" tIns="0" bIns="0">
+          <a:bodyPr wrap="square" lIns="0" tIns="0" rIns="0" bIns="0" anchor="t">
             <a:spAutoFit/>
           </a:bodyPr>
           <a:lstStyle/>
@@ -18734,7 +18959,7 @@
           <a:noFill/>
         </p:spPr>
         <p:txBody>
-          <a:bodyPr wrap="square" anchor="t" lIns="0" rIns="0" tIns="0" bIns="0">
+          <a:bodyPr wrap="square" lIns="0" tIns="0" rIns="0" bIns="0" anchor="t">
             <a:spAutoFit/>
           </a:bodyPr>
           <a:lstStyle/>
@@ -18769,7 +18994,7 @@
           <a:noFill/>
         </p:spPr>
         <p:txBody>
-          <a:bodyPr wrap="square" anchor="t" lIns="0" rIns="0" tIns="0" bIns="0">
+          <a:bodyPr wrap="square" lIns="0" tIns="0" rIns="0" bIns="0" anchor="t">
             <a:spAutoFit/>
           </a:bodyPr>
           <a:lstStyle/>
@@ -18829,6 +19054,7 @@
           <a:lstStyle/>
           <a:p>
             <a:pPr algn="ctr"/>
+            <a:endParaRPr/>
           </a:p>
         </p:txBody>
       </p:sp>
@@ -18872,6 +19098,7 @@
           <a:lstStyle/>
           <a:p>
             <a:pPr algn="ctr"/>
+            <a:endParaRPr/>
           </a:p>
         </p:txBody>
       </p:sp>
@@ -18915,6 +19142,7 @@
           <a:lstStyle/>
           <a:p>
             <a:pPr algn="ctr"/>
+            <a:endParaRPr/>
           </a:p>
         </p:txBody>
       </p:sp>
@@ -18935,7 +19163,7 @@
           <a:noFill/>
         </p:spPr>
         <p:txBody>
-          <a:bodyPr wrap="square" anchor="t" lIns="0" rIns="0" tIns="0" bIns="0">
+          <a:bodyPr wrap="square" lIns="0" tIns="0" rIns="0" bIns="0" anchor="t">
             <a:spAutoFit/>
           </a:bodyPr>
           <a:lstStyle/>
@@ -18970,7 +19198,7 @@
           <a:noFill/>
         </p:spPr>
         <p:txBody>
-          <a:bodyPr wrap="square" anchor="t" lIns="0" rIns="0" tIns="0" bIns="0">
+          <a:bodyPr wrap="square" lIns="0" tIns="0" rIns="0" bIns="0" anchor="t">
             <a:spAutoFit/>
           </a:bodyPr>
           <a:lstStyle/>
@@ -19005,7 +19233,7 @@
           <a:noFill/>
         </p:spPr>
         <p:txBody>
-          <a:bodyPr wrap="square" anchor="t" lIns="0" rIns="0" tIns="0" bIns="0">
+          <a:bodyPr wrap="square" lIns="0" tIns="0" rIns="0" bIns="0" anchor="t">
             <a:spAutoFit/>
           </a:bodyPr>
           <a:lstStyle/>
@@ -19040,7 +19268,7 @@
           <a:noFill/>
         </p:spPr>
         <p:txBody>
-          <a:bodyPr wrap="square" anchor="t" lIns="0" rIns="0" tIns="0" bIns="0">
+          <a:bodyPr wrap="square" lIns="0" tIns="0" rIns="0" bIns="0" anchor="t">
             <a:spAutoFit/>
           </a:bodyPr>
           <a:lstStyle/>
@@ -19100,6 +19328,7 @@
           <a:lstStyle/>
           <a:p>
             <a:pPr algn="ctr"/>
+            <a:endParaRPr/>
           </a:p>
         </p:txBody>
       </p:sp>
@@ -19143,6 +19372,7 @@
           <a:lstStyle/>
           <a:p>
             <a:pPr algn="ctr"/>
+            <a:endParaRPr/>
           </a:p>
         </p:txBody>
       </p:sp>
@@ -19186,6 +19416,7 @@
           <a:lstStyle/>
           <a:p>
             <a:pPr algn="ctr"/>
+            <a:endParaRPr/>
           </a:p>
         </p:txBody>
       </p:sp>
@@ -19206,7 +19437,7 @@
           <a:noFill/>
         </p:spPr>
         <p:txBody>
-          <a:bodyPr wrap="square" anchor="t" lIns="0" rIns="0" tIns="0" bIns="0">
+          <a:bodyPr wrap="square" lIns="0" tIns="0" rIns="0" bIns="0" anchor="t">
             <a:spAutoFit/>
           </a:bodyPr>
           <a:lstStyle/>
@@ -19241,7 +19472,7 @@
           <a:noFill/>
         </p:spPr>
         <p:txBody>
-          <a:bodyPr wrap="square" anchor="t" lIns="0" rIns="0" tIns="0" bIns="0">
+          <a:bodyPr wrap="square" lIns="0" tIns="0" rIns="0" bIns="0" anchor="t">
             <a:spAutoFit/>
           </a:bodyPr>
           <a:lstStyle/>
@@ -19276,7 +19507,7 @@
           <a:noFill/>
         </p:spPr>
         <p:txBody>
-          <a:bodyPr wrap="square" anchor="t" lIns="0" rIns="0" tIns="0" bIns="0">
+          <a:bodyPr wrap="square" lIns="0" tIns="0" rIns="0" bIns="0" anchor="t">
             <a:spAutoFit/>
           </a:bodyPr>
           <a:lstStyle/>
@@ -19311,7 +19542,7 @@
           <a:noFill/>
         </p:spPr>
         <p:txBody>
-          <a:bodyPr wrap="square" anchor="t" lIns="0" rIns="0" tIns="0" bIns="0">
+          <a:bodyPr wrap="square" lIns="0" tIns="0" rIns="0" bIns="0" anchor="t">
             <a:spAutoFit/>
           </a:bodyPr>
           <a:lstStyle/>
@@ -19346,7 +19577,7 @@
           <a:noFill/>
         </p:spPr>
         <p:txBody>
-          <a:bodyPr wrap="square" anchor="t" lIns="0" rIns="0" tIns="0" bIns="0">
+          <a:bodyPr wrap="square" lIns="0" tIns="0" rIns="0" bIns="0" anchor="t">
             <a:spAutoFit/>
           </a:bodyPr>
           <a:lstStyle/>
@@ -19381,7 +19612,7 @@
           <a:noFill/>
         </p:spPr>
         <p:txBody>
-          <a:bodyPr wrap="square" anchor="t" lIns="0" rIns="0" tIns="0" bIns="0">
+          <a:bodyPr wrap="square" lIns="0" tIns="0" rIns="0" bIns="0" anchor="t">
             <a:spAutoFit/>
           </a:bodyPr>
           <a:lstStyle/>

</xml_diff>